<commit_message>
Add game production workflow slides to the pitch deck
Two new slides cover the six-step build (premise, rules, screenwriter,
craft, playtest, Pages) and the daily six-file engineering loop.

Co-authored-by: szekangylp <szekangylp@gmail.com>
</commit_message>
<xml_diff>
--- a/docs/青嵐世家-3分鐘簡報.pptx
+++ b/docs/青嵐世家-3分鐘簡報.pptx
@@ -13,6 +13,8 @@
     <p:sldId id="261" r:id="rId13"/>
     <p:sldId id="262" r:id="rId14"/>
     <p:sldId id="263" r:id="rId15"/>
+    <p:sldId id="264" r:id="rId16"/>
+    <p:sldId id="265" r:id="rId17"/>
   </p:sldIdLst>
   <p:sldSz cx="12191695" cy="6858000" type="screen4x3"/>
   <p:notesSz cx="6858000" cy="9144000"/>
@@ -534,7 +536,97 @@
           </a:p>
           <a:p>
             <a:r>
-              <a:t>今日三分鐘：做咩、點玩、點同《教父》同 AI 編劇夾埋。</a:t>
+              <a:t>今日三分鐘：做咩、點做出嚟、點玩。</a:t>
+            </a:r>
+          </a:p>
+        </p:txBody>
+      </p:sp>
+      <p:sp>
+        <p:nvSpPr>
+          <p:cNvPr id="4" name="Slide Number Placeholder 3"/>
+          <p:cNvSpPr>
+            <a:spLocks noGrp="1"/>
+          </p:cNvSpPr>
+          <p:nvPr>
+            <p:ph type="sldNum" idx="5" sz="quarter"/>
+          </p:nvPr>
+        </p:nvSpPr>
+        <p:spPr/>
+      </p:sp>
+    </p:spTree>
+  </p:cSld>
+  <p:clrMapOvr>
+    <a:masterClrMapping/>
+  </p:clrMapOvr>
+</p:notes>
+</file>
+
+<file path=ppt/notesSlides/notesSlide10.xml><?xml version="1.0" encoding="utf-8"?>
+<p:notes xmlns:a="http://schemas.openxmlformats.org/drawingml/2006/main" xmlns:p="http://schemas.openxmlformats.org/presentationml/2006/main" xmlns:r="http://schemas.openxmlformats.org/officeDocument/2006/relationships">
+  <p:cSld>
+    <p:spTree>
+      <p:nvGrpSpPr>
+        <p:cNvPr id="1" name=""/>
+        <p:cNvGrpSpPr/>
+        <p:nvPr/>
+      </p:nvGrpSpPr>
+      <p:grpSpPr>
+        <a:xfrm>
+          <a:off x="0" y="0"/>
+          <a:ext cx="0" cy="0"/>
+          <a:chOff x="0" y="0"/>
+          <a:chExt cx="0" cy="0"/>
+        </a:xfrm>
+      </p:grpSpPr>
+      <p:sp>
+        <p:nvSpPr>
+          <p:cNvPr id="2" name="Slide Image Placeholder 1"/>
+          <p:cNvSpPr>
+            <a:spLocks noGrp="1"/>
+          </p:cNvSpPr>
+          <p:nvPr>
+            <p:ph type="sldImg" idx="2"/>
+          </p:nvPr>
+        </p:nvSpPr>
+        <p:spPr/>
+      </p:sp>
+      <p:sp>
+        <p:nvSpPr>
+          <p:cNvPr id="3" name="Notes Placeholder 2"/>
+          <p:cNvSpPr>
+            <a:spLocks noGrp="1"/>
+          </p:cNvSpPr>
+          <p:nvPr>
+            <p:ph type="body" idx="3" sz="quarter"/>
+          </p:nvPr>
+        </p:nvSpPr>
+        <p:spPr/>
+        <p:txBody>
+          <a:bodyPr/>
+          <a:lstStyle/>
+          <a:p>
+            <a:r>
+              <a:t>收束。</a:t>
+            </a:r>
+          </a:p>
+          <a:p>
+            <a:r>
+              <a:t>青嵐世家想證明：放置遊戲可以係一場有人、有怨、有遺產嘅戲，而唔係一條升級曲線。</a:t>
+            </a:r>
+          </a:p>
+          <a:p>
+            <a:r>
+              <a:t>你係天道。少出手。睇住人。</a:t>
+            </a:r>
+          </a:p>
+          <a:p>
+            <a:r>
+              <a:t>連結再講一次：github.io/family 同 github.com/yip-lgtm/family。</a:t>
+            </a:r>
+          </a:p>
+          <a:p>
+            <a:r>
+              <a:t>多謝。歡迎而家一齊開。</a:t>
             </a:r>
           </a:p>
         </p:txBody>
@@ -1054,32 +1146,32 @@
           <a:lstStyle/>
           <a:p>
             <a:r>
-              <a:t>示範四步。</a:t>
-            </a:r>
-          </a:p>
-          <a:p>
-            <a:r>
-              <a:t>一：打開 yip-lgtm.github.io/family ，撳承天命。</a:t>
-            </a:r>
-          </a:p>
-          <a:p>
-            <a:r>
-              <a:t>二：點一個角色，睇心事。建議先睇沈清梧同葉疏影——佢哋有舊怨，戲先有衝突。</a:t>
-            </a:r>
-          </a:p>
-          <a:p>
-            <a:r>
-              <a:t>三：開時間，等編劇組兩場。第一幕會寫權力同聯姻。</a:t>
-            </a:r>
-          </a:p>
-          <a:p>
-            <a:r>
-              <a:t>四：只用一次天道：賜福或者天劫。然後停手。好嘅天道唔係不停改，而係改完就睇。</a:t>
-            </a:r>
-          </a:p>
-          <a:p>
-            <a:r>
-              <a:t>可選：模型設定貼 OpenRouter Key，之後嘅戲會更貼近現場。冇 Key 一樣完整。</a:t>
+              <a:t>製作唔係先畫皮。先問：玩家係邊個？答案係天道。</a:t>
+            </a:r>
+          </a:p>
+          <a:p>
+            <a:r>
+              <a:t>第二先寫規則引擎 world.js：每個月人自己揀去邊、會病、會走火、會死，業力先可以改命。</a:t>
+            </a:r>
+          </a:p>
+          <a:p>
+            <a:r>
+              <a:t>第三先有編劇組 screenplay.js：三幕致敬教父節奏，劇組代班保證冇 Key 都有戲。</a:t>
+            </a:r>
+          </a:p>
+          <a:p>
+            <a:r>
+              <a:t>第四先上金漆：CSS、Canvas、Web Audio、嗶哩官方嵌入。無外部圖，Pages 先載得快。</a:t>
+            </a:r>
+          </a:p>
+          <a:p>
+            <a:r>
+              <a:t>第五現場試：Vite 開 /family/，改完即睇。BGM 太大、文案唔順，呢一步先修。</a:t>
+            </a:r>
+          </a:p>
+          <a:p>
+            <a:r>
+              <a:t>第六出貨：npm run build，推 gh-pages，base 設 /family/，就係而家呢個站。</a:t>
             </a:r>
           </a:p>
         </p:txBody>
@@ -1149,27 +1241,122 @@
           <a:lstStyle/>
           <a:p>
             <a:r>
-              <a:t>收束。</a:t>
-            </a:r>
-          </a:p>
-          <a:p>
-            <a:r>
-              <a:t>青嵐世家想證明：放置遊戲可以係一場有人、有怨、有遺產嘅戲，而唔係一條升級曲線。</a:t>
-            </a:r>
-          </a:p>
-          <a:p>
-            <a:r>
-              <a:t>你係天道。少出手。睇住人。</a:t>
-            </a:r>
-          </a:p>
-          <a:p>
-            <a:r>
-              <a:t>連結再講一次：github.io/family 同 github.com/yip-lgtm/family。</a:t>
-            </a:r>
-          </a:p>
-          <a:p>
-            <a:r>
-              <a:t>多謝。歡迎而家一齊開。</a:t>
+              <a:t>工程刻意薄：六個檔，冇框架組件庫。</a:t>
+            </a:r>
+          </a:p>
+          <a:p>
+            <a:r>
+              <a:t>world 管規則，screenplay 管戲，main 管天道介面，style、fx、audio 管現場。</a:t>
+            </a:r>
+          </a:p>
+          <a:p>
+            <a:r>
+              <a:t>每日回路就係：改一條規則或者一句文案，開 Vite 睇，覺得山門仲似一間屋，先 commit。</a:t>
+            </a:r>
+          </a:p>
+          <a:p>
+            <a:r>
+              <a:t>出貨唔使後端：build 完推 gh-pages，base 係 /family/。</a:t>
+            </a:r>
+          </a:p>
+          <a:p>
+            <a:r>
+              <a:t>三條紅線：唔偷嗶哩音、唔抄教父對白、Key 唔上伺服器。劇組代班永遠兜底。</a:t>
+            </a:r>
+          </a:p>
+        </p:txBody>
+      </p:sp>
+      <p:sp>
+        <p:nvSpPr>
+          <p:cNvPr id="4" name="Slide Number Placeholder 3"/>
+          <p:cNvSpPr>
+            <a:spLocks noGrp="1"/>
+          </p:cNvSpPr>
+          <p:nvPr>
+            <p:ph type="sldNum" idx="5" sz="quarter"/>
+          </p:nvPr>
+        </p:nvSpPr>
+        <p:spPr/>
+      </p:sp>
+    </p:spTree>
+  </p:cSld>
+  <p:clrMapOvr>
+    <a:masterClrMapping/>
+  </p:clrMapOvr>
+</p:notes>
+</file>
+
+<file path=ppt/notesSlides/notesSlide9.xml><?xml version="1.0" encoding="utf-8"?>
+<p:notes xmlns:a="http://schemas.openxmlformats.org/drawingml/2006/main" xmlns:p="http://schemas.openxmlformats.org/presentationml/2006/main" xmlns:r="http://schemas.openxmlformats.org/officeDocument/2006/relationships">
+  <p:cSld>
+    <p:spTree>
+      <p:nvGrpSpPr>
+        <p:cNvPr id="1" name=""/>
+        <p:cNvGrpSpPr/>
+        <p:nvPr/>
+      </p:nvGrpSpPr>
+      <p:grpSpPr>
+        <a:xfrm>
+          <a:off x="0" y="0"/>
+          <a:ext cx="0" cy="0"/>
+          <a:chOff x="0" y="0"/>
+          <a:chExt cx="0" cy="0"/>
+        </a:xfrm>
+      </p:grpSpPr>
+      <p:sp>
+        <p:nvSpPr>
+          <p:cNvPr id="2" name="Slide Image Placeholder 1"/>
+          <p:cNvSpPr>
+            <a:spLocks noGrp="1"/>
+          </p:cNvSpPr>
+          <p:nvPr>
+            <p:ph type="sldImg" idx="2"/>
+          </p:nvPr>
+        </p:nvSpPr>
+        <p:spPr/>
+      </p:sp>
+      <p:sp>
+        <p:nvSpPr>
+          <p:cNvPr id="3" name="Notes Placeholder 2"/>
+          <p:cNvSpPr>
+            <a:spLocks noGrp="1"/>
+          </p:cNvSpPr>
+          <p:nvPr>
+            <p:ph type="body" idx="3" sz="quarter"/>
+          </p:nvPr>
+        </p:nvSpPr>
+        <p:spPr/>
+        <p:txBody>
+          <a:bodyPr/>
+          <a:lstStyle/>
+          <a:p>
+            <a:r>
+              <a:t>示範四步。</a:t>
+            </a:r>
+          </a:p>
+          <a:p>
+            <a:r>
+              <a:t>一：打開 yip-lgtm.github.io/family ，撳承天命。</a:t>
+            </a:r>
+          </a:p>
+          <a:p>
+            <a:r>
+              <a:t>二：點一個角色，睇心事。建議先睇沈清梧同葉疏影——佢哋有舊怨，戲先有衝突。</a:t>
+            </a:r>
+          </a:p>
+          <a:p>
+            <a:r>
+              <a:t>三：開時間，等編劇組兩場。第一幕會寫權力同聯姻。</a:t>
+            </a:r>
+          </a:p>
+          <a:p>
+            <a:r>
+              <a:t>四：只用一次天道：賜福或者天劫。然後停手。好嘅天道唔係不停改，而係改完就睇。</a:t>
+            </a:r>
+          </a:p>
+          <a:p>
+            <a:r>
+              <a:t>可選：模型設定貼 OpenRouter Key，之後嘅戲會更貼近現場。冇 Key 一樣完整。</a:t>
             </a:r>
           </a:p>
         </p:txBody>
@@ -4424,7 +4611,7 @@
                 <a:latin typeface="Microsoft YaHei"/>
                 <a:ea typeface="Microsoft YaHei"/>
               </a:rPr>
-              <a:t>3 分鐘產品簡報  ·  GitHub Pages</a:t>
+              <a:t>約 3 分鐘  ·  含製作 workflow</a:t>
             </a:r>
           </a:p>
           <a:p>
@@ -4459,6 +4646,312 @@
                 <a:ea typeface="Microsoft YaHei"/>
               </a:rPr>
               <a:t>源碼：https://github.com/yip-lgtm/family.git</a:t>
+            </a:r>
+          </a:p>
+        </p:txBody>
+      </p:sp>
+    </p:spTree>
+  </p:cSld>
+  <p:clrMapOvr>
+    <a:masterClrMapping/>
+  </p:clrMapOvr>
+</p:sld>
+</file>
+
+<file path=ppt/slides/slide10.xml><?xml version="1.0" encoding="utf-8"?>
+<p:sld xmlns:a="http://schemas.openxmlformats.org/drawingml/2006/main" xmlns:p="http://schemas.openxmlformats.org/presentationml/2006/main" xmlns:r="http://schemas.openxmlformats.org/officeDocument/2006/relationships">
+  <p:cSld>
+    <p:bg>
+      <p:bgPr>
+        <a:solidFill>
+          <a:srgbClr val="0B0804"/>
+        </a:solidFill>
+        <a:effectLst/>
+      </p:bgPr>
+    </p:bg>
+    <p:spTree>
+      <p:nvGrpSpPr>
+        <p:cNvPr id="1" name=""/>
+        <p:cNvGrpSpPr/>
+        <p:nvPr/>
+      </p:nvGrpSpPr>
+      <p:grpSpPr/>
+      <p:sp>
+        <p:nvSpPr>
+          <p:cNvPr id="2" name="Rectangle 1"/>
+          <p:cNvSpPr/>
+          <p:nvPr/>
+        </p:nvSpPr>
+        <p:spPr>
+          <a:xfrm>
+            <a:off x="0" y="0"/>
+            <a:ext cx="12191695" cy="54864"/>
+          </a:xfrm>
+          <a:prstGeom prst="rect">
+            <a:avLst/>
+          </a:prstGeom>
+          <a:solidFill>
+            <a:srgbClr val="D4AF37"/>
+          </a:solidFill>
+          <a:ln>
+            <a:noFill/>
+          </a:ln>
+        </p:spPr>
+        <p:style>
+          <a:lnRef idx="1">
+            <a:schemeClr val="accent1"/>
+          </a:lnRef>
+          <a:fillRef idx="3">
+            <a:schemeClr val="accent1"/>
+          </a:fillRef>
+          <a:effectRef idx="2">
+            <a:schemeClr val="accent1"/>
+          </a:effectRef>
+          <a:fontRef idx="minor">
+            <a:schemeClr val="lt1"/>
+          </a:fontRef>
+        </p:style>
+        <p:txBody>
+          <a:bodyPr rtlCol="0" anchor="ctr"/>
+          <a:lstStyle/>
+          <a:p>
+            <a:pPr algn="ctr"/>
+          </a:p>
+        </p:txBody>
+      </p:sp>
+      <p:sp>
+        <p:nvSpPr>
+          <p:cNvPr id="3" name="Rectangle 2"/>
+          <p:cNvSpPr/>
+          <p:nvPr/>
+        </p:nvSpPr>
+        <p:spPr>
+          <a:xfrm>
+            <a:off x="0" y="6803136"/>
+            <a:ext cx="12191695" cy="54864"/>
+          </a:xfrm>
+          <a:prstGeom prst="rect">
+            <a:avLst/>
+          </a:prstGeom>
+          <a:solidFill>
+            <a:srgbClr val="D4AF37"/>
+          </a:solidFill>
+          <a:ln>
+            <a:noFill/>
+          </a:ln>
+        </p:spPr>
+        <p:style>
+          <a:lnRef idx="1">
+            <a:schemeClr val="accent1"/>
+          </a:lnRef>
+          <a:fillRef idx="3">
+            <a:schemeClr val="accent1"/>
+          </a:fillRef>
+          <a:effectRef idx="2">
+            <a:schemeClr val="accent1"/>
+          </a:effectRef>
+          <a:fontRef idx="minor">
+            <a:schemeClr val="lt1"/>
+          </a:fontRef>
+        </p:style>
+        <p:txBody>
+          <a:bodyPr rtlCol="0" anchor="ctr"/>
+          <a:lstStyle/>
+          <a:p>
+            <a:pPr algn="ctr"/>
+          </a:p>
+        </p:txBody>
+      </p:sp>
+      <p:sp>
+        <p:nvSpPr>
+          <p:cNvPr id="4" name="TextBox 3"/>
+          <p:cNvSpPr txBox="1"/>
+          <p:nvPr/>
+        </p:nvSpPr>
+        <p:spPr>
+          <a:xfrm>
+            <a:off x="731520" y="1234440"/>
+            <a:ext cx="10698480" cy="457200"/>
+          </a:xfrm>
+          <a:prstGeom prst="rect">
+            <a:avLst/>
+          </a:prstGeom>
+          <a:noFill/>
+        </p:spPr>
+        <p:txBody>
+          <a:bodyPr wrap="square">
+            <a:spAutoFit/>
+          </a:bodyPr>
+          <a:lstStyle/>
+          <a:p>
+            <a:pPr algn="ctr">
+              <a:spcAft>
+                <a:spcPts val="600"/>
+              </a:spcAft>
+            </a:pPr>
+            <a:r>
+              <a:rPr sz="1400" b="0">
+                <a:solidFill>
+                  <a:srgbClr val="D4AF37"/>
+                </a:solidFill>
+                <a:latin typeface="Microsoft YaHei"/>
+                <a:ea typeface="Microsoft YaHei"/>
+              </a:rPr>
+              <a:t>結  ·  家訓</a:t>
+            </a:r>
+          </a:p>
+        </p:txBody>
+      </p:sp>
+      <p:sp>
+        <p:nvSpPr>
+          <p:cNvPr id="5" name="TextBox 4"/>
+          <p:cNvSpPr txBox="1"/>
+          <p:nvPr/>
+        </p:nvSpPr>
+        <p:spPr>
+          <a:xfrm>
+            <a:off x="731520" y="1737360"/>
+            <a:ext cx="10698480" cy="1280160"/>
+          </a:xfrm>
+          <a:prstGeom prst="rect">
+            <a:avLst/>
+          </a:prstGeom>
+          <a:noFill/>
+        </p:spPr>
+        <p:txBody>
+          <a:bodyPr wrap="square">
+            <a:spAutoFit/>
+          </a:bodyPr>
+          <a:lstStyle/>
+          <a:p>
+            <a:pPr algn="ctr">
+              <a:spcAft>
+                <a:spcPts val="600"/>
+              </a:spcAft>
+            </a:pPr>
+            <a:r>
+              <a:rPr sz="3200" b="1">
+                <a:solidFill>
+                  <a:srgbClr val="D4AF37"/>
+                </a:solidFill>
+                <a:latin typeface="Microsoft YaHei"/>
+                <a:ea typeface="Microsoft YaHei"/>
+              </a:rPr>
+              <a:t>人死功法在。家在，戲就未完。</a:t>
+            </a:r>
+          </a:p>
+        </p:txBody>
+      </p:sp>
+      <p:sp>
+        <p:nvSpPr>
+          <p:cNvPr id="6" name="TextBox 5"/>
+          <p:cNvSpPr txBox="1"/>
+          <p:nvPr/>
+        </p:nvSpPr>
+        <p:spPr>
+          <a:xfrm>
+            <a:off x="731520" y="3108960"/>
+            <a:ext cx="10698480" cy="1463040"/>
+          </a:xfrm>
+          <a:prstGeom prst="rect">
+            <a:avLst/>
+          </a:prstGeom>
+          <a:noFill/>
+        </p:spPr>
+        <p:txBody>
+          <a:bodyPr wrap="square">
+            <a:spAutoFit/>
+          </a:bodyPr>
+          <a:lstStyle/>
+          <a:p>
+            <a:pPr algn="ctr">
+              <a:spcAft>
+                <a:spcPts val="600"/>
+              </a:spcAft>
+            </a:pPr>
+            <a:r>
+              <a:rPr sz="2000" b="1">
+                <a:solidFill>
+                  <a:srgbClr val="7EC8C3"/>
+                </a:solidFill>
+                <a:latin typeface="Microsoft YaHei"/>
+                <a:ea typeface="Microsoft YaHei"/>
+              </a:rPr>
+              <a:t>玩　　https://yip-lgtm.github.io/family/</a:t>
+            </a:r>
+          </a:p>
+          <a:p>
+            <a:pPr algn="ctr">
+              <a:spcAft>
+                <a:spcPts val="600"/>
+              </a:spcAft>
+            </a:pPr>
+            <a:r>
+              <a:rPr sz="1800" b="0">
+                <a:solidFill>
+                  <a:srgbClr val="B8A888"/>
+                </a:solidFill>
+                <a:latin typeface="Microsoft YaHei"/>
+                <a:ea typeface="Microsoft YaHei"/>
+              </a:rPr>
+              <a:t>源碼　https://github.com/yip-lgtm/family.git</a:t>
+            </a:r>
+          </a:p>
+          <a:p>
+            <a:pPr algn="ctr">
+              <a:spcAft>
+                <a:spcPts val="600"/>
+              </a:spcAft>
+            </a:pPr>
+            <a:r>
+              <a:rPr sz="1600" b="0">
+                <a:solidFill>
+                  <a:srgbClr val="B8A888"/>
+                </a:solidFill>
+                <a:latin typeface="Microsoft YaHei"/>
+                <a:ea typeface="Microsoft YaHei"/>
+              </a:rPr>
+              <a:t>鏡像　https://github.com/yip-lgtm/qi-lineage</a:t>
+            </a:r>
+          </a:p>
+        </p:txBody>
+      </p:sp>
+      <p:sp>
+        <p:nvSpPr>
+          <p:cNvPr id="7" name="TextBox 6"/>
+          <p:cNvSpPr txBox="1"/>
+          <p:nvPr/>
+        </p:nvSpPr>
+        <p:spPr>
+          <a:xfrm>
+            <a:off x="731520" y="5029200"/>
+            <a:ext cx="10698480" cy="731520"/>
+          </a:xfrm>
+          <a:prstGeom prst="rect">
+            <a:avLst/>
+          </a:prstGeom>
+          <a:noFill/>
+        </p:spPr>
+        <p:txBody>
+          <a:bodyPr wrap="square">
+            <a:spAutoFit/>
+          </a:bodyPr>
+          <a:lstStyle/>
+          <a:p>
+            <a:pPr algn="ctr">
+              <a:spcAft>
+                <a:spcPts val="600"/>
+              </a:spcAft>
+            </a:pPr>
+            <a:r>
+              <a:rPr sz="1600" b="0">
+                <a:solidFill>
+                  <a:srgbClr val="B8A888"/>
+                </a:solidFill>
+                <a:latin typeface="Microsoft YaHei"/>
+                <a:ea typeface="Microsoft YaHei"/>
+              </a:rPr>
+              <a:t>開源 · 瀏覽器即玩 · Key 可選 · 劇組永遠代班</a:t>
             </a:r>
           </a:p>
         </p:txBody>
@@ -8680,7 +9173,7 @@
         </p:nvSpPr>
         <p:spPr>
           <a:xfrm>
-            <a:off x="640080" y="274320"/>
+            <a:off x="640080" y="256032"/>
             <a:ext cx="10972800" cy="777240"/>
           </a:xfrm>
           <a:prstGeom prst="rect">
@@ -8707,7 +9200,7 @@
                 <a:latin typeface="Microsoft YaHei"/>
                 <a:ea typeface="Microsoft YaHei"/>
               </a:rPr>
-              <a:t>06  ·  而家點玩（三分鐘）</a:t>
+              <a:t>06  ·  遊戲製作 workflow</a:t>
             </a:r>
           </a:p>
           <a:p>
@@ -8717,14 +9210,14 @@
               </a:spcAft>
             </a:pPr>
             <a:r>
-              <a:rPr sz="2800" b="1">
+              <a:rPr sz="2600" b="1">
                 <a:solidFill>
                   <a:srgbClr val="F4E8C8"/>
                 </a:solidFill>
                 <a:latin typeface="Microsoft YaHei"/>
                 <a:ea typeface="Microsoft YaHei"/>
               </a:rPr>
-              <a:t>四步入局，唔使註冊</a:t>
+              <a:t>先立天道，再寫規則，最後先上金漆</a:t>
             </a:r>
           </a:p>
         </p:txBody>
@@ -8737,8 +9230,8 @@
         </p:nvSpPr>
         <p:spPr>
           <a:xfrm>
-            <a:off x="457200" y="1325880"/>
-            <a:ext cx="2743200" cy="4297680"/>
+            <a:off x="457200" y="1234440"/>
+            <a:ext cx="3657600" cy="2377440"/>
           </a:xfrm>
           <a:prstGeom prst="roundRect">
             <a:avLst/>
@@ -8782,8 +9275,8 @@
         </p:nvSpPr>
         <p:spPr>
           <a:xfrm>
-            <a:off x="640080" y="1554480"/>
-            <a:ext cx="2377440" cy="640080"/>
+            <a:off x="640080" y="1399032"/>
+            <a:ext cx="3291840" cy="365760"/>
           </a:xfrm>
           <a:prstGeom prst="rect">
             <a:avLst/>
@@ -8796,20 +9289,20 @@
           </a:bodyPr>
           <a:lstStyle/>
           <a:p>
-            <a:pPr algn="ctr">
-              <a:spcAft>
-                <a:spcPts val="600"/>
-              </a:spcAft>
-            </a:pPr>
-            <a:r>
-              <a:rPr sz="3600" b="1">
+            <a:pPr algn="l">
+              <a:spcAft>
+                <a:spcPts val="600"/>
+              </a:spcAft>
+            </a:pPr>
+            <a:r>
+              <a:rPr sz="1800" b="1">
                 <a:solidFill>
                   <a:srgbClr val="D4AF37"/>
                 </a:solidFill>
                 <a:latin typeface="Microsoft YaHei"/>
                 <a:ea typeface="Microsoft YaHei"/>
               </a:rPr>
-              <a:t>1</a:t>
+              <a:t>1  ·  立意</a:t>
             </a:r>
           </a:p>
         </p:txBody>
@@ -8822,8 +9315,8 @@
         </p:nvSpPr>
         <p:spPr>
           <a:xfrm>
-            <a:off x="640080" y="2286000"/>
-            <a:ext cx="2377440" cy="640080"/>
+            <a:off x="640080" y="1874520"/>
+            <a:ext cx="3291840" cy="1554480"/>
           </a:xfrm>
           <a:prstGeom prst="rect">
             <a:avLst/>
@@ -8836,47 +9329,24 @@
           </a:bodyPr>
           <a:lstStyle/>
           <a:p>
-            <a:pPr algn="ctr">
-              <a:spcAft>
-                <a:spcPts val="600"/>
-              </a:spcAft>
-            </a:pPr>
-            <a:r>
-              <a:rPr sz="1800" b="1">
+            <a:pPr algn="l">
+              <a:spcAft>
+                <a:spcPts val="600"/>
+              </a:spcAft>
+            </a:pPr>
+            <a:r>
+              <a:rPr sz="1500" b="0">
                 <a:solidFill>
                   <a:srgbClr val="F4E8C8"/>
                 </a:solidFill>
                 <a:latin typeface="Microsoft YaHei"/>
                 <a:ea typeface="Microsoft YaHei"/>
               </a:rPr>
-              <a:t>打開連結</a:t>
-            </a:r>
-          </a:p>
-        </p:txBody>
-      </p:sp>
-      <p:sp>
-        <p:nvSpPr>
-          <p:cNvPr id="8" name="TextBox 7"/>
-          <p:cNvSpPr txBox="1"/>
-          <p:nvPr/>
-        </p:nvSpPr>
-        <p:spPr>
-          <a:xfrm>
-            <a:off x="594360" y="3063240"/>
-            <a:ext cx="2468880" cy="2194560"/>
-          </a:xfrm>
-          <a:prstGeom prst="rect">
-            <a:avLst/>
-          </a:prstGeom>
-          <a:noFill/>
-        </p:spPr>
-        <p:txBody>
-          <a:bodyPr wrap="square">
-            <a:spAutoFit/>
-          </a:bodyPr>
-          <a:lstStyle/>
-          <a:p>
-            <a:pPr algn="ctr">
+              <a:t>玩家係天道。</a:t>
+            </a:r>
+          </a:p>
+          <a:p>
+            <a:pPr algn="l">
               <a:spcAft>
                 <a:spcPts val="600"/>
               </a:spcAft>
@@ -8884,27 +9354,43 @@
             <a:r>
               <a:rPr sz="1500" b="0">
                 <a:solidFill>
-                  <a:srgbClr val="B8A888"/>
-                </a:solidFill>
-                <a:latin typeface="Microsoft YaHei"/>
-                <a:ea typeface="Microsoft YaHei"/>
-              </a:rPr>
-              <a:t>yip-lgtm.github.io/family
-撳「承天命」。</a:t>
-            </a:r>
-          </a:p>
-        </p:txBody>
-      </p:sp>
-      <p:sp>
-        <p:nvSpPr>
-          <p:cNvPr id="9" name="Rounded Rectangle 8"/>
+                  <a:srgbClr val="F4E8C8"/>
+                </a:solidFill>
+                <a:latin typeface="Microsoft YaHei"/>
+                <a:ea typeface="Microsoft YaHei"/>
+              </a:rPr>
+              <a:t>養人、改命、睇戲。</a:t>
+            </a:r>
+          </a:p>
+          <a:p>
+            <a:pPr algn="l">
+              <a:spcAft>
+                <a:spcPts val="600"/>
+              </a:spcAft>
+            </a:pPr>
+            <a:r>
+              <a:rPr sz="1500" b="0">
+                <a:solidFill>
+                  <a:srgbClr val="F4E8C8"/>
+                </a:solidFill>
+                <a:latin typeface="Microsoft YaHei"/>
+                <a:ea typeface="Microsoft YaHei"/>
+              </a:rPr>
+              <a:t>唔做點擊農夫。</a:t>
+            </a:r>
+          </a:p>
+        </p:txBody>
+      </p:sp>
+      <p:sp>
+        <p:nvSpPr>
+          <p:cNvPr id="8" name="Rounded Rectangle 7"/>
           <p:cNvSpPr/>
           <p:nvPr/>
         </p:nvSpPr>
         <p:spPr>
           <a:xfrm>
-            <a:off x="3383280" y="1325880"/>
-            <a:ext cx="2743200" cy="4297680"/>
+            <a:off x="4297680" y="1234440"/>
+            <a:ext cx="3657600" cy="2377440"/>
           </a:xfrm>
           <a:prstGeom prst="roundRect">
             <a:avLst/>
@@ -8942,14 +9428,14 @@
       </p:sp>
       <p:sp>
         <p:nvSpPr>
-          <p:cNvPr id="10" name="TextBox 9"/>
+          <p:cNvPr id="9" name="TextBox 8"/>
           <p:cNvSpPr txBox="1"/>
           <p:nvPr/>
         </p:nvSpPr>
         <p:spPr>
           <a:xfrm>
-            <a:off x="3566160" y="1554480"/>
-            <a:ext cx="2377440" cy="640080"/>
+            <a:off x="4480560" y="1399032"/>
+            <a:ext cx="3291840" cy="365760"/>
           </a:xfrm>
           <a:prstGeom prst="rect">
             <a:avLst/>
@@ -8962,34 +9448,34 @@
           </a:bodyPr>
           <a:lstStyle/>
           <a:p>
-            <a:pPr algn="ctr">
-              <a:spcAft>
-                <a:spcPts val="600"/>
-              </a:spcAft>
-            </a:pPr>
-            <a:r>
-              <a:rPr sz="3600" b="1">
+            <a:pPr algn="l">
+              <a:spcAft>
+                <a:spcPts val="600"/>
+              </a:spcAft>
+            </a:pPr>
+            <a:r>
+              <a:rPr sz="1800" b="1">
                 <a:solidFill>
                   <a:srgbClr val="D4AF37"/>
                 </a:solidFill>
                 <a:latin typeface="Microsoft YaHei"/>
                 <a:ea typeface="Microsoft YaHei"/>
               </a:rPr>
-              <a:t>2</a:t>
-            </a:r>
-          </a:p>
-        </p:txBody>
-      </p:sp>
-      <p:sp>
-        <p:nvSpPr>
-          <p:cNvPr id="11" name="TextBox 10"/>
+              <a:t>2  ·  規則</a:t>
+            </a:r>
+          </a:p>
+        </p:txBody>
+      </p:sp>
+      <p:sp>
+        <p:nvSpPr>
+          <p:cNvPr id="10" name="TextBox 9"/>
           <p:cNvSpPr txBox="1"/>
           <p:nvPr/>
         </p:nvSpPr>
         <p:spPr>
           <a:xfrm>
-            <a:off x="3566160" y="2286000"/>
-            <a:ext cx="2377440" cy="640080"/>
+            <a:off x="4480560" y="1874520"/>
+            <a:ext cx="3291840" cy="1554480"/>
           </a:xfrm>
           <a:prstGeom prst="rect">
             <a:avLst/>
@@ -9002,47 +9488,24 @@
           </a:bodyPr>
           <a:lstStyle/>
           <a:p>
-            <a:pPr algn="ctr">
-              <a:spcAft>
-                <a:spcPts val="600"/>
-              </a:spcAft>
-            </a:pPr>
-            <a:r>
-              <a:rPr sz="1800" b="1">
+            <a:pPr algn="l">
+              <a:spcAft>
+                <a:spcPts val="600"/>
+              </a:spcAft>
+            </a:pPr>
+            <a:r>
+              <a:rPr sz="1500" b="0">
                 <a:solidFill>
                   <a:srgbClr val="F4E8C8"/>
                 </a:solidFill>
                 <a:latin typeface="Microsoft YaHei"/>
                 <a:ea typeface="Microsoft YaHei"/>
               </a:rPr>
-              <a:t>睇一個人</a:t>
-            </a:r>
-          </a:p>
-        </p:txBody>
-      </p:sp>
-      <p:sp>
-        <p:nvSpPr>
-          <p:cNvPr id="12" name="TextBox 11"/>
-          <p:cNvSpPr txBox="1"/>
-          <p:nvPr/>
-        </p:nvSpPr>
-        <p:spPr>
-          <a:xfrm>
-            <a:off x="3520440" y="3063240"/>
-            <a:ext cx="2468880" cy="2194560"/>
-          </a:xfrm>
-          <a:prstGeom prst="rect">
-            <a:avLst/>
-          </a:prstGeom>
-          <a:noFill/>
-        </p:spPr>
-        <p:txBody>
-          <a:bodyPr wrap="square">
-            <a:spAutoFit/>
-          </a:bodyPr>
-          <a:lstStyle/>
-          <a:p>
-            <a:pPr algn="ctr">
+              <a:t>world.js</a:t>
+            </a:r>
+          </a:p>
+          <a:p>
+            <a:pPr algn="l">
               <a:spcAft>
                 <a:spcPts val="600"/>
               </a:spcAft>
@@ -9050,27 +9513,43 @@
             <a:r>
               <a:rPr sz="1500" b="0">
                 <a:solidFill>
-                  <a:srgbClr val="B8A888"/>
-                </a:solidFill>
-                <a:latin typeface="Microsoft YaHei"/>
-                <a:ea typeface="Microsoft YaHei"/>
-              </a:rPr>
-              <a:t>點沈清梧或者葉疏影。
-記住佢心事同關係。</a:t>
-            </a:r>
-          </a:p>
-        </p:txBody>
-      </p:sp>
-      <p:sp>
-        <p:nvSpPr>
-          <p:cNvPr id="13" name="Rounded Rectangle 12"/>
+                  <a:srgbClr val="F4E8C8"/>
+                </a:solidFill>
+                <a:latin typeface="Microsoft YaHei"/>
+                <a:ea typeface="Microsoft YaHei"/>
+              </a:rPr>
+              <a:t>月結、根骨、壽元</a:t>
+            </a:r>
+          </a:p>
+          <a:p>
+            <a:pPr algn="l">
+              <a:spcAft>
+                <a:spcPts val="600"/>
+              </a:spcAft>
+            </a:pPr>
+            <a:r>
+              <a:rPr sz="1500" b="0">
+                <a:solidFill>
+                  <a:srgbClr val="F4E8C8"/>
+                </a:solidFill>
+                <a:latin typeface="Microsoft YaHei"/>
+                <a:ea typeface="Microsoft YaHei"/>
+              </a:rPr>
+              <a:t>業力、死亡、傳承。</a:t>
+            </a:r>
+          </a:p>
+        </p:txBody>
+      </p:sp>
+      <p:sp>
+        <p:nvSpPr>
+          <p:cNvPr id="11" name="Rounded Rectangle 10"/>
           <p:cNvSpPr/>
           <p:nvPr/>
         </p:nvSpPr>
         <p:spPr>
           <a:xfrm>
-            <a:off x="6309360" y="1325880"/>
-            <a:ext cx="2743200" cy="4297680"/>
+            <a:off x="8138160" y="1234440"/>
+            <a:ext cx="3657600" cy="2377440"/>
           </a:xfrm>
           <a:prstGeom prst="roundRect">
             <a:avLst/>
@@ -9108,14 +9587,14 @@
       </p:sp>
       <p:sp>
         <p:nvSpPr>
-          <p:cNvPr id="14" name="TextBox 13"/>
+          <p:cNvPr id="12" name="TextBox 11"/>
           <p:cNvSpPr txBox="1"/>
           <p:nvPr/>
         </p:nvSpPr>
         <p:spPr>
           <a:xfrm>
-            <a:off x="6492240" y="1554480"/>
-            <a:ext cx="2377440" cy="640080"/>
+            <a:off x="8321040" y="1399032"/>
+            <a:ext cx="3291840" cy="365760"/>
           </a:xfrm>
           <a:prstGeom prst="rect">
             <a:avLst/>
@@ -9128,34 +9607,34 @@
           </a:bodyPr>
           <a:lstStyle/>
           <a:p>
-            <a:pPr algn="ctr">
-              <a:spcAft>
-                <a:spcPts val="600"/>
-              </a:spcAft>
-            </a:pPr>
-            <a:r>
-              <a:rPr sz="3600" b="1">
+            <a:pPr algn="l">
+              <a:spcAft>
+                <a:spcPts val="600"/>
+              </a:spcAft>
+            </a:pPr>
+            <a:r>
+              <a:rPr sz="1800" b="1">
                 <a:solidFill>
                   <a:srgbClr val="D4AF37"/>
                 </a:solidFill>
                 <a:latin typeface="Microsoft YaHei"/>
                 <a:ea typeface="Microsoft YaHei"/>
               </a:rPr>
-              <a:t>3</a:t>
-            </a:r>
-          </a:p>
-        </p:txBody>
-      </p:sp>
-      <p:sp>
-        <p:nvSpPr>
-          <p:cNvPr id="15" name="TextBox 14"/>
+              <a:t>3  ·  編劇</a:t>
+            </a:r>
+          </a:p>
+        </p:txBody>
+      </p:sp>
+      <p:sp>
+        <p:nvSpPr>
+          <p:cNvPr id="13" name="TextBox 12"/>
           <p:cNvSpPr txBox="1"/>
           <p:nvPr/>
         </p:nvSpPr>
         <p:spPr>
           <a:xfrm>
-            <a:off x="6492240" y="2286000"/>
-            <a:ext cx="2377440" cy="640080"/>
+            <a:off x="8321040" y="1874520"/>
+            <a:ext cx="3291840" cy="1554480"/>
           </a:xfrm>
           <a:prstGeom prst="rect">
             <a:avLst/>
@@ -9168,47 +9647,24 @@
           </a:bodyPr>
           <a:lstStyle/>
           <a:p>
-            <a:pPr algn="ctr">
-              <a:spcAft>
-                <a:spcPts val="600"/>
-              </a:spcAft>
-            </a:pPr>
-            <a:r>
-              <a:rPr sz="1800" b="1">
+            <a:pPr algn="l">
+              <a:spcAft>
+                <a:spcPts val="600"/>
+              </a:spcAft>
+            </a:pPr>
+            <a:r>
+              <a:rPr sz="1500" b="0">
                 <a:solidFill>
                   <a:srgbClr val="F4E8C8"/>
                 </a:solidFill>
                 <a:latin typeface="Microsoft YaHei"/>
                 <a:ea typeface="Microsoft YaHei"/>
               </a:rPr>
-              <a:t>等兩場戲</a:t>
-            </a:r>
-          </a:p>
-        </p:txBody>
-      </p:sp>
-      <p:sp>
-        <p:nvSpPr>
-          <p:cNvPr id="16" name="TextBox 15"/>
-          <p:cNvSpPr txBox="1"/>
-          <p:nvPr/>
-        </p:nvSpPr>
-        <p:spPr>
-          <a:xfrm>
-            <a:off x="6446520" y="3063240"/>
-            <a:ext cx="2468880" cy="2194560"/>
-          </a:xfrm>
-          <a:prstGeom prst="rect">
-            <a:avLst/>
-          </a:prstGeom>
-          <a:noFill/>
-        </p:spPr>
-        <p:txBody>
-          <a:bodyPr wrap="square">
-            <a:spAutoFit/>
-          </a:bodyPr>
-          <a:lstStyle/>
-          <a:p>
-            <a:pPr algn="ctr">
+              <a:t>screenplay.js</a:t>
+            </a:r>
+          </a:p>
+          <a:p>
+            <a:pPr algn="l">
               <a:spcAft>
                 <a:spcPts val="600"/>
               </a:spcAft>
@@ -9216,26 +9672,43 @@
             <a:r>
               <a:rPr sz="1500" b="0">
                 <a:solidFill>
-                  <a:srgbClr val="B8A888"/>
-                </a:solidFill>
-                <a:latin typeface="Microsoft YaHei"/>
-                <a:ea typeface="Microsoft YaHei"/>
-              </a:rPr>
-              <a:t>開時間。睇編劇組出第一、第二場。</a:t>
-            </a:r>
-          </a:p>
-        </p:txBody>
-      </p:sp>
-      <p:sp>
-        <p:nvSpPr>
-          <p:cNvPr id="17" name="Rounded Rectangle 16"/>
+                  <a:srgbClr val="F4E8C8"/>
+                </a:solidFill>
+                <a:latin typeface="Microsoft YaHei"/>
+                <a:ea typeface="Microsoft YaHei"/>
+              </a:rPr>
+              <a:t>三幕節奏 + 劇組代班。</a:t>
+            </a:r>
+          </a:p>
+          <a:p>
+            <a:pPr algn="l">
+              <a:spcAft>
+                <a:spcPts val="600"/>
+              </a:spcAft>
+            </a:pPr>
+            <a:r>
+              <a:rPr sz="1500" b="0">
+                <a:solidFill>
+                  <a:srgbClr val="F4E8C8"/>
+                </a:solidFill>
+                <a:latin typeface="Microsoft YaHei"/>
+                <a:ea typeface="Microsoft YaHei"/>
+              </a:rPr>
+              <a:t>戲寫入心事同關係。</a:t>
+            </a:r>
+          </a:p>
+        </p:txBody>
+      </p:sp>
+      <p:sp>
+        <p:nvSpPr>
+          <p:cNvPr id="14" name="Rounded Rectangle 13"/>
           <p:cNvSpPr/>
           <p:nvPr/>
         </p:nvSpPr>
         <p:spPr>
           <a:xfrm>
-            <a:off x="9235440" y="1325880"/>
-            <a:ext cx="2743200" cy="4297680"/>
+            <a:off x="457200" y="3794760"/>
+            <a:ext cx="3657600" cy="2377440"/>
           </a:xfrm>
           <a:prstGeom prst="roundRect">
             <a:avLst/>
@@ -9273,14 +9746,14 @@
       </p:sp>
       <p:sp>
         <p:nvSpPr>
-          <p:cNvPr id="18" name="TextBox 17"/>
+          <p:cNvPr id="15" name="TextBox 14"/>
           <p:cNvSpPr txBox="1"/>
           <p:nvPr/>
         </p:nvSpPr>
         <p:spPr>
           <a:xfrm>
-            <a:off x="9418320" y="1554480"/>
-            <a:ext cx="2377440" cy="640080"/>
+            <a:off x="640080" y="3959352"/>
+            <a:ext cx="3291840" cy="365760"/>
           </a:xfrm>
           <a:prstGeom prst="rect">
             <a:avLst/>
@@ -9293,34 +9766,34 @@
           </a:bodyPr>
           <a:lstStyle/>
           <a:p>
-            <a:pPr algn="ctr">
-              <a:spcAft>
-                <a:spcPts val="600"/>
-              </a:spcAft>
-            </a:pPr>
-            <a:r>
-              <a:rPr sz="3600" b="1">
+            <a:pPr algn="l">
+              <a:spcAft>
+                <a:spcPts val="600"/>
+              </a:spcAft>
+            </a:pPr>
+            <a:r>
+              <a:rPr sz="1800" b="1">
                 <a:solidFill>
                   <a:srgbClr val="D4AF37"/>
                 </a:solidFill>
                 <a:latin typeface="Microsoft YaHei"/>
                 <a:ea typeface="Microsoft YaHei"/>
               </a:rPr>
-              <a:t>4</a:t>
-            </a:r>
-          </a:p>
-        </p:txBody>
-      </p:sp>
-      <p:sp>
-        <p:nvSpPr>
-          <p:cNvPr id="19" name="TextBox 18"/>
+              <a:t>4  ·  皮與聲</a:t>
+            </a:r>
+          </a:p>
+        </p:txBody>
+      </p:sp>
+      <p:sp>
+        <p:nvSpPr>
+          <p:cNvPr id="16" name="TextBox 15"/>
           <p:cNvSpPr txBox="1"/>
           <p:nvPr/>
         </p:nvSpPr>
         <p:spPr>
           <a:xfrm>
-            <a:off x="9418320" y="2286000"/>
-            <a:ext cx="2377440" cy="640080"/>
+            <a:off x="640080" y="4434840"/>
+            <a:ext cx="3291840" cy="1554480"/>
           </a:xfrm>
           <a:prstGeom prst="rect">
             <a:avLst/>
@@ -9333,34 +9806,113 @@
           </a:bodyPr>
           <a:lstStyle/>
           <a:p>
-            <a:pPr algn="ctr">
-              <a:spcAft>
-                <a:spcPts val="600"/>
-              </a:spcAft>
-            </a:pPr>
-            <a:r>
-              <a:rPr sz="1800" b="1">
+            <a:pPr algn="l">
+              <a:spcAft>
+                <a:spcPts val="600"/>
+              </a:spcAft>
+            </a:pPr>
+            <a:r>
+              <a:rPr sz="1500" b="0">
                 <a:solidFill>
                   <a:srgbClr val="F4E8C8"/>
                 </a:solidFill>
                 <a:latin typeface="Microsoft YaHei"/>
                 <a:ea typeface="Microsoft YaHei"/>
               </a:rPr>
-              <a:t>先改一次命</a:t>
-            </a:r>
-          </a:p>
-        </p:txBody>
-      </p:sp>
-      <p:sp>
-        <p:nvSpPr>
-          <p:cNvPr id="20" name="TextBox 19"/>
+              <a:t>CSS 金漆、Canvas 靈塵、</a:t>
+            </a:r>
+          </a:p>
+          <a:p>
+            <a:pPr algn="l">
+              <a:spcAft>
+                <a:spcPts val="600"/>
+              </a:spcAft>
+            </a:pPr>
+            <a:r>
+              <a:rPr sz="1500" b="0">
+                <a:solidFill>
+                  <a:srgbClr val="F4E8C8"/>
+                </a:solidFill>
+                <a:latin typeface="Microsoft YaHei"/>
+                <a:ea typeface="Microsoft YaHei"/>
+              </a:rPr>
+              <a:t>Web Audio、嗶哩嵌入。</a:t>
+            </a:r>
+          </a:p>
+          <a:p>
+            <a:pPr algn="l">
+              <a:spcAft>
+                <a:spcPts val="600"/>
+              </a:spcAft>
+            </a:pPr>
+            <a:r>
+              <a:rPr sz="1500" b="0">
+                <a:solidFill>
+                  <a:srgbClr val="F4E8C8"/>
+                </a:solidFill>
+                <a:latin typeface="Microsoft YaHei"/>
+                <a:ea typeface="Microsoft YaHei"/>
+              </a:rPr>
+              <a:t>零外鏈圖。</a:t>
+            </a:r>
+          </a:p>
+        </p:txBody>
+      </p:sp>
+      <p:sp>
+        <p:nvSpPr>
+          <p:cNvPr id="17" name="Rounded Rectangle 16"/>
+          <p:cNvSpPr/>
+          <p:nvPr/>
+        </p:nvSpPr>
+        <p:spPr>
+          <a:xfrm>
+            <a:off x="4297680" y="3794760"/>
+            <a:ext cx="3657600" cy="2377440"/>
+          </a:xfrm>
+          <a:prstGeom prst="roundRect">
+            <a:avLst/>
+          </a:prstGeom>
+          <a:solidFill>
+            <a:srgbClr val="14100A"/>
+          </a:solidFill>
+          <a:ln w="15875">
+            <a:solidFill>
+              <a:srgbClr val="D4AF37"/>
+            </a:solidFill>
+          </a:ln>
+        </p:spPr>
+        <p:style>
+          <a:lnRef idx="1">
+            <a:schemeClr val="accent1"/>
+          </a:lnRef>
+          <a:fillRef idx="3">
+            <a:schemeClr val="accent1"/>
+          </a:fillRef>
+          <a:effectRef idx="2">
+            <a:schemeClr val="accent1"/>
+          </a:effectRef>
+          <a:fontRef idx="minor">
+            <a:schemeClr val="lt1"/>
+          </a:fontRef>
+        </p:style>
+        <p:txBody>
+          <a:bodyPr rtlCol="0" anchor="ctr"/>
+          <a:lstStyle/>
+          <a:p>
+            <a:pPr algn="ctr"/>
+          </a:p>
+        </p:txBody>
+      </p:sp>
+      <p:sp>
+        <p:nvSpPr>
+          <p:cNvPr id="18" name="TextBox 17"/>
           <p:cNvSpPr txBox="1"/>
           <p:nvPr/>
         </p:nvSpPr>
         <p:spPr>
           <a:xfrm>
-            <a:off x="9372600" y="3063240"/>
-            <a:ext cx="2468880" cy="2194560"/>
+            <a:off x="4480560" y="3959352"/>
+            <a:ext cx="3291840" cy="365760"/>
           </a:xfrm>
           <a:prstGeom prst="rect">
             <a:avLst/>
@@ -9373,7 +9925,47 @@
           </a:bodyPr>
           <a:lstStyle/>
           <a:p>
-            <a:pPr algn="ctr">
+            <a:pPr algn="l">
+              <a:spcAft>
+                <a:spcPts val="600"/>
+              </a:spcAft>
+            </a:pPr>
+            <a:r>
+              <a:rPr sz="1800" b="1">
+                <a:solidFill>
+                  <a:srgbClr val="D4AF37"/>
+                </a:solidFill>
+                <a:latin typeface="Microsoft YaHei"/>
+                <a:ea typeface="Microsoft YaHei"/>
+              </a:rPr>
+              <a:t>5  ·  試玩</a:t>
+            </a:r>
+          </a:p>
+        </p:txBody>
+      </p:sp>
+      <p:sp>
+        <p:nvSpPr>
+          <p:cNvPr id="19" name="TextBox 18"/>
+          <p:cNvSpPr txBox="1"/>
+          <p:nvPr/>
+        </p:nvSpPr>
+        <p:spPr>
+          <a:xfrm>
+            <a:off x="4480560" y="4434840"/>
+            <a:ext cx="3291840" cy="1554480"/>
+          </a:xfrm>
+          <a:prstGeom prst="rect">
+            <a:avLst/>
+          </a:prstGeom>
+          <a:noFill/>
+        </p:spPr>
+        <p:txBody>
+          <a:bodyPr wrap="square">
+            <a:spAutoFit/>
+          </a:bodyPr>
+          <a:lstStyle/>
+          <a:p>
+            <a:pPr algn="l">
               <a:spcAft>
                 <a:spcPts val="600"/>
               </a:spcAft>
@@ -9381,13 +9973,205 @@
             <a:r>
               <a:rPr sz="1500" b="0">
                 <a:solidFill>
-                  <a:srgbClr val="B8A888"/>
-                </a:solidFill>
-                <a:latin typeface="Microsoft YaHei"/>
-                <a:ea typeface="Microsoft YaHei"/>
-              </a:rPr>
-              <a:t>賜福或者天劫。
-然後停手，睇後果。</a:t>
+                  <a:srgbClr val="F4E8C8"/>
+                </a:solidFill>
+                <a:latin typeface="Microsoft YaHei"/>
+                <a:ea typeface="Microsoft YaHei"/>
+              </a:rPr>
+              <a:t>Vite 開 /family/</a:t>
+            </a:r>
+          </a:p>
+          <a:p>
+            <a:pPr algn="l">
+              <a:spcAft>
+                <a:spcPts val="600"/>
+              </a:spcAft>
+            </a:pPr>
+            <a:r>
+              <a:rPr sz="1500" b="0">
+                <a:solidFill>
+                  <a:srgbClr val="F4E8C8"/>
+                </a:solidFill>
+                <a:latin typeface="Microsoft YaHei"/>
+                <a:ea typeface="Microsoft YaHei"/>
+              </a:rPr>
+              <a:t>改完即睇。</a:t>
+            </a:r>
+          </a:p>
+          <a:p>
+            <a:pPr algn="l">
+              <a:spcAft>
+                <a:spcPts val="600"/>
+              </a:spcAft>
+            </a:pPr>
+            <a:r>
+              <a:rPr sz="1500" b="0">
+                <a:solidFill>
+                  <a:srgbClr val="F4E8C8"/>
+                </a:solidFill>
+                <a:latin typeface="Microsoft YaHei"/>
+                <a:ea typeface="Microsoft YaHei"/>
+              </a:rPr>
+              <a:t>細畫面、BGM、文案。</a:t>
+            </a:r>
+          </a:p>
+        </p:txBody>
+      </p:sp>
+      <p:sp>
+        <p:nvSpPr>
+          <p:cNvPr id="20" name="Rounded Rectangle 19"/>
+          <p:cNvSpPr/>
+          <p:nvPr/>
+        </p:nvSpPr>
+        <p:spPr>
+          <a:xfrm>
+            <a:off x="8138160" y="3794760"/>
+            <a:ext cx="3657600" cy="2377440"/>
+          </a:xfrm>
+          <a:prstGeom prst="roundRect">
+            <a:avLst/>
+          </a:prstGeom>
+          <a:solidFill>
+            <a:srgbClr val="14100A"/>
+          </a:solidFill>
+          <a:ln w="15875">
+            <a:solidFill>
+              <a:srgbClr val="D4AF37"/>
+            </a:solidFill>
+          </a:ln>
+        </p:spPr>
+        <p:style>
+          <a:lnRef idx="1">
+            <a:schemeClr val="accent1"/>
+          </a:lnRef>
+          <a:fillRef idx="3">
+            <a:schemeClr val="accent1"/>
+          </a:fillRef>
+          <a:effectRef idx="2">
+            <a:schemeClr val="accent1"/>
+          </a:effectRef>
+          <a:fontRef idx="minor">
+            <a:schemeClr val="lt1"/>
+          </a:fontRef>
+        </p:style>
+        <p:txBody>
+          <a:bodyPr rtlCol="0" anchor="ctr"/>
+          <a:lstStyle/>
+          <a:p>
+            <a:pPr algn="ctr"/>
+          </a:p>
+        </p:txBody>
+      </p:sp>
+      <p:sp>
+        <p:nvSpPr>
+          <p:cNvPr id="21" name="TextBox 20"/>
+          <p:cNvSpPr txBox="1"/>
+          <p:nvPr/>
+        </p:nvSpPr>
+        <p:spPr>
+          <a:xfrm>
+            <a:off x="8321040" y="3959352"/>
+            <a:ext cx="3291840" cy="365760"/>
+          </a:xfrm>
+          <a:prstGeom prst="rect">
+            <a:avLst/>
+          </a:prstGeom>
+          <a:noFill/>
+        </p:spPr>
+        <p:txBody>
+          <a:bodyPr wrap="square">
+            <a:spAutoFit/>
+          </a:bodyPr>
+          <a:lstStyle/>
+          <a:p>
+            <a:pPr algn="l">
+              <a:spcAft>
+                <a:spcPts val="600"/>
+              </a:spcAft>
+            </a:pPr>
+            <a:r>
+              <a:rPr sz="1800" b="1">
+                <a:solidFill>
+                  <a:srgbClr val="D4AF37"/>
+                </a:solidFill>
+                <a:latin typeface="Microsoft YaHei"/>
+                <a:ea typeface="Microsoft YaHei"/>
+              </a:rPr>
+              <a:t>6  ·  出貨</a:t>
+            </a:r>
+          </a:p>
+        </p:txBody>
+      </p:sp>
+      <p:sp>
+        <p:nvSpPr>
+          <p:cNvPr id="22" name="TextBox 21"/>
+          <p:cNvSpPr txBox="1"/>
+          <p:nvPr/>
+        </p:nvSpPr>
+        <p:spPr>
+          <a:xfrm>
+            <a:off x="8321040" y="4434840"/>
+            <a:ext cx="3291840" cy="1554480"/>
+          </a:xfrm>
+          <a:prstGeom prst="rect">
+            <a:avLst/>
+          </a:prstGeom>
+          <a:noFill/>
+        </p:spPr>
+        <p:txBody>
+          <a:bodyPr wrap="square">
+            <a:spAutoFit/>
+          </a:bodyPr>
+          <a:lstStyle/>
+          <a:p>
+            <a:pPr algn="l">
+              <a:spcAft>
+                <a:spcPts val="600"/>
+              </a:spcAft>
+            </a:pPr>
+            <a:r>
+              <a:rPr sz="1500" b="0">
+                <a:solidFill>
+                  <a:srgbClr val="F4E8C8"/>
+                </a:solidFill>
+                <a:latin typeface="Microsoft YaHei"/>
+                <a:ea typeface="Microsoft YaHei"/>
+              </a:rPr>
+              <a:t>npm run build</a:t>
+            </a:r>
+          </a:p>
+          <a:p>
+            <a:pPr algn="l">
+              <a:spcAft>
+                <a:spcPts val="600"/>
+              </a:spcAft>
+            </a:pPr>
+            <a:r>
+              <a:rPr sz="1500" b="0">
+                <a:solidFill>
+                  <a:srgbClr val="F4E8C8"/>
+                </a:solidFill>
+                <a:latin typeface="Microsoft YaHei"/>
+                <a:ea typeface="Microsoft YaHei"/>
+              </a:rPr>
+              <a:t>推 gh-pages。</a:t>
+            </a:r>
+          </a:p>
+          <a:p>
+            <a:pPr algn="l">
+              <a:spcAft>
+                <a:spcPts val="600"/>
+              </a:spcAft>
+            </a:pPr>
+            <a:r>
+              <a:rPr sz="1500" b="0">
+                <a:solidFill>
+                  <a:srgbClr val="F4E8C8"/>
+                </a:solidFill>
+                <a:latin typeface="Microsoft YaHei"/>
+                <a:ea typeface="Microsoft YaHei"/>
+              </a:rPr>
+              <a:t>github.io/family</a:t>
             </a:r>
           </a:p>
         </p:txBody>
@@ -9512,8 +10296,8 @@
         </p:nvSpPr>
         <p:spPr>
           <a:xfrm>
-            <a:off x="731520" y="1234440"/>
-            <a:ext cx="10698480" cy="457200"/>
+            <a:off x="640080" y="256032"/>
+            <a:ext cx="10972800" cy="777240"/>
           </a:xfrm>
           <a:prstGeom prst="rect">
             <a:avLst/>
@@ -9526,7 +10310,7 @@
           </a:bodyPr>
           <a:lstStyle/>
           <a:p>
-            <a:pPr algn="ctr">
+            <a:pPr algn="l">
               <a:spcAft>
                 <a:spcPts val="600"/>
               </a:spcAft>
@@ -9539,21 +10323,83 @@
                 <a:latin typeface="Microsoft YaHei"/>
                 <a:ea typeface="Microsoft YaHei"/>
               </a:rPr>
-              <a:t>結  ·  家訓</a:t>
-            </a:r>
-          </a:p>
-        </p:txBody>
-      </p:sp>
-      <p:sp>
-        <p:nvSpPr>
-          <p:cNvPr id="5" name="TextBox 4"/>
+              <a:t>07  ·  工程回路</a:t>
+            </a:r>
+          </a:p>
+          <a:p>
+            <a:pPr algn="l">
+              <a:spcAft>
+                <a:spcPts val="600"/>
+              </a:spcAft>
+            </a:pPr>
+            <a:r>
+              <a:rPr sz="2600" b="1">
+                <a:solidFill>
+                  <a:srgbClr val="F4E8C8"/>
+                </a:solidFill>
+                <a:latin typeface="Microsoft YaHei"/>
+                <a:ea typeface="Microsoft YaHei"/>
+              </a:rPr>
+              <a:t>六個檔，一條每日回路：改 → 睇 → 推</a:t>
+            </a:r>
+          </a:p>
+        </p:txBody>
+      </p:sp>
+      <p:sp>
+        <p:nvSpPr>
+          <p:cNvPr id="5" name="Rounded Rectangle 4"/>
+          <p:cNvSpPr/>
+          <p:nvPr/>
+        </p:nvSpPr>
+        <p:spPr>
+          <a:xfrm>
+            <a:off x="457200" y="1170432"/>
+            <a:ext cx="3657600" cy="1389888"/>
+          </a:xfrm>
+          <a:prstGeom prst="roundRect">
+            <a:avLst/>
+          </a:prstGeom>
+          <a:solidFill>
+            <a:srgbClr val="14100A"/>
+          </a:solidFill>
+          <a:ln w="15875">
+            <a:solidFill>
+              <a:srgbClr val="D4AF37"/>
+            </a:solidFill>
+          </a:ln>
+        </p:spPr>
+        <p:style>
+          <a:lnRef idx="1">
+            <a:schemeClr val="accent1"/>
+          </a:lnRef>
+          <a:fillRef idx="3">
+            <a:schemeClr val="accent1"/>
+          </a:fillRef>
+          <a:effectRef idx="2">
+            <a:schemeClr val="accent1"/>
+          </a:effectRef>
+          <a:fontRef idx="minor">
+            <a:schemeClr val="lt1"/>
+          </a:fontRef>
+        </p:style>
+        <p:txBody>
+          <a:bodyPr rtlCol="0" anchor="ctr"/>
+          <a:lstStyle/>
+          <a:p>
+            <a:pPr algn="ctr"/>
+          </a:p>
+        </p:txBody>
+      </p:sp>
+      <p:sp>
+        <p:nvSpPr>
+          <p:cNvPr id="6" name="TextBox 5"/>
           <p:cNvSpPr txBox="1"/>
           <p:nvPr/>
         </p:nvSpPr>
         <p:spPr>
           <a:xfrm>
-            <a:off x="731520" y="1737360"/>
-            <a:ext cx="10698480" cy="1280160"/>
+            <a:off x="640080" y="1335024"/>
+            <a:ext cx="3291840" cy="365760"/>
           </a:xfrm>
           <a:prstGeom prst="rect">
             <a:avLst/>
@@ -9566,34 +10412,34 @@
           </a:bodyPr>
           <a:lstStyle/>
           <a:p>
-            <a:pPr algn="ctr">
-              <a:spcAft>
-                <a:spcPts val="600"/>
-              </a:spcAft>
-            </a:pPr>
-            <a:r>
-              <a:rPr sz="3200" b="1">
-                <a:solidFill>
-                  <a:srgbClr val="D4AF37"/>
-                </a:solidFill>
-                <a:latin typeface="Microsoft YaHei"/>
-                <a:ea typeface="Microsoft YaHei"/>
-              </a:rPr>
-              <a:t>人死功法在。家在，戲就未完。</a:t>
-            </a:r>
-          </a:p>
-        </p:txBody>
-      </p:sp>
-      <p:sp>
-        <p:nvSpPr>
-          <p:cNvPr id="6" name="TextBox 5"/>
+            <a:pPr algn="l">
+              <a:spcAft>
+                <a:spcPts val="600"/>
+              </a:spcAft>
+            </a:pPr>
+            <a:r>
+              <a:rPr sz="1800" b="1">
+                <a:solidFill>
+                  <a:srgbClr val="7EC8C3"/>
+                </a:solidFill>
+                <a:latin typeface="Microsoft YaHei"/>
+                <a:ea typeface="Microsoft YaHei"/>
+              </a:rPr>
+              <a:t>world.js</a:t>
+            </a:r>
+          </a:p>
+        </p:txBody>
+      </p:sp>
+      <p:sp>
+        <p:nvSpPr>
+          <p:cNvPr id="7" name="TextBox 6"/>
           <p:cNvSpPr txBox="1"/>
           <p:nvPr/>
         </p:nvSpPr>
         <p:spPr>
           <a:xfrm>
-            <a:off x="731520" y="3108960"/>
-            <a:ext cx="10698480" cy="1463040"/>
+            <a:off x="640080" y="1792224"/>
+            <a:ext cx="3291840" cy="548640"/>
           </a:xfrm>
           <a:prstGeom prst="rect">
             <a:avLst/>
@@ -9606,68 +10452,79 @@
           </a:bodyPr>
           <a:lstStyle/>
           <a:p>
-            <a:pPr algn="ctr">
-              <a:spcAft>
-                <a:spcPts val="600"/>
-              </a:spcAft>
-            </a:pPr>
-            <a:r>
-              <a:rPr sz="2000" b="1">
-                <a:solidFill>
-                  <a:srgbClr val="7EC8C3"/>
-                </a:solidFill>
-                <a:latin typeface="Microsoft YaHei"/>
-                <a:ea typeface="Microsoft YaHei"/>
-              </a:rPr>
-              <a:t>玩　　https://yip-lgtm.github.io/family/</a:t>
-            </a:r>
-          </a:p>
-          <a:p>
-            <a:pPr algn="ctr">
-              <a:spcAft>
-                <a:spcPts val="600"/>
-              </a:spcAft>
-            </a:pPr>
-            <a:r>
-              <a:rPr sz="1800" b="0">
-                <a:solidFill>
-                  <a:srgbClr val="B8A888"/>
-                </a:solidFill>
-                <a:latin typeface="Microsoft YaHei"/>
-                <a:ea typeface="Microsoft YaHei"/>
-              </a:rPr>
-              <a:t>源碼　https://github.com/yip-lgtm/family.git</a:t>
-            </a:r>
-          </a:p>
-          <a:p>
-            <a:pPr algn="ctr">
-              <a:spcAft>
-                <a:spcPts val="600"/>
-              </a:spcAft>
-            </a:pPr>
-            <a:r>
-              <a:rPr sz="1600" b="0">
-                <a:solidFill>
-                  <a:srgbClr val="B8A888"/>
-                </a:solidFill>
-                <a:latin typeface="Microsoft YaHei"/>
-                <a:ea typeface="Microsoft YaHei"/>
-              </a:rPr>
-              <a:t>鏡像　https://github.com/yip-lgtm/qi-lineage</a:t>
-            </a:r>
-          </a:p>
-        </p:txBody>
-      </p:sp>
-      <p:sp>
-        <p:nvSpPr>
-          <p:cNvPr id="7" name="TextBox 6"/>
+            <a:pPr algn="l">
+              <a:spcAft>
+                <a:spcPts val="600"/>
+              </a:spcAft>
+            </a:pPr>
+            <a:r>
+              <a:rPr sz="1500" b="0">
+                <a:solidFill>
+                  <a:srgbClr val="F4E8C8"/>
+                </a:solidFill>
+                <a:latin typeface="Microsoft YaHei"/>
+                <a:ea typeface="Microsoft YaHei"/>
+              </a:rPr>
+              <a:t>月結、人物、天道三鍵</a:t>
+            </a:r>
+          </a:p>
+        </p:txBody>
+      </p:sp>
+      <p:sp>
+        <p:nvSpPr>
+          <p:cNvPr id="8" name="Rounded Rectangle 7"/>
+          <p:cNvSpPr/>
+          <p:nvPr/>
+        </p:nvSpPr>
+        <p:spPr>
+          <a:xfrm>
+            <a:off x="4297680" y="1170432"/>
+            <a:ext cx="3657600" cy="1389888"/>
+          </a:xfrm>
+          <a:prstGeom prst="roundRect">
+            <a:avLst/>
+          </a:prstGeom>
+          <a:solidFill>
+            <a:srgbClr val="14100A"/>
+          </a:solidFill>
+          <a:ln w="15875">
+            <a:solidFill>
+              <a:srgbClr val="D4AF37"/>
+            </a:solidFill>
+          </a:ln>
+        </p:spPr>
+        <p:style>
+          <a:lnRef idx="1">
+            <a:schemeClr val="accent1"/>
+          </a:lnRef>
+          <a:fillRef idx="3">
+            <a:schemeClr val="accent1"/>
+          </a:fillRef>
+          <a:effectRef idx="2">
+            <a:schemeClr val="accent1"/>
+          </a:effectRef>
+          <a:fontRef idx="minor">
+            <a:schemeClr val="lt1"/>
+          </a:fontRef>
+        </p:style>
+        <p:txBody>
+          <a:bodyPr rtlCol="0" anchor="ctr"/>
+          <a:lstStyle/>
+          <a:p>
+            <a:pPr algn="ctr"/>
+          </a:p>
+        </p:txBody>
+      </p:sp>
+      <p:sp>
+        <p:nvSpPr>
+          <p:cNvPr id="9" name="TextBox 8"/>
           <p:cNvSpPr txBox="1"/>
           <p:nvPr/>
         </p:nvSpPr>
         <p:spPr>
           <a:xfrm>
-            <a:off x="731520" y="5029200"/>
-            <a:ext cx="10698480" cy="731520"/>
+            <a:off x="4480560" y="1335024"/>
+            <a:ext cx="3291840" cy="365760"/>
           </a:xfrm>
           <a:prstGeom prst="rect">
             <a:avLst/>
@@ -9680,20 +10537,1511 @@
           </a:bodyPr>
           <a:lstStyle/>
           <a:p>
+            <a:pPr algn="l">
+              <a:spcAft>
+                <a:spcPts val="600"/>
+              </a:spcAft>
+            </a:pPr>
+            <a:r>
+              <a:rPr sz="1800" b="1">
+                <a:solidFill>
+                  <a:srgbClr val="7EC8C3"/>
+                </a:solidFill>
+                <a:latin typeface="Microsoft YaHei"/>
+                <a:ea typeface="Microsoft YaHei"/>
+              </a:rPr>
+              <a:t>screenplay.js</a:t>
+            </a:r>
+          </a:p>
+        </p:txBody>
+      </p:sp>
+      <p:sp>
+        <p:nvSpPr>
+          <p:cNvPr id="10" name="TextBox 9"/>
+          <p:cNvSpPr txBox="1"/>
+          <p:nvPr/>
+        </p:nvSpPr>
+        <p:spPr>
+          <a:xfrm>
+            <a:off x="4480560" y="1792224"/>
+            <a:ext cx="3291840" cy="548640"/>
+          </a:xfrm>
+          <a:prstGeom prst="rect">
+            <a:avLst/>
+          </a:prstGeom>
+          <a:noFill/>
+        </p:spPr>
+        <p:txBody>
+          <a:bodyPr wrap="square">
+            <a:spAutoFit/>
+          </a:bodyPr>
+          <a:lstStyle/>
+          <a:p>
+            <a:pPr algn="l">
+              <a:spcAft>
+                <a:spcPts val="600"/>
+              </a:spcAft>
+            </a:pPr>
+            <a:r>
+              <a:rPr sz="1500" b="0">
+                <a:solidFill>
+                  <a:srgbClr val="F4E8C8"/>
+                </a:solidFill>
+                <a:latin typeface="Microsoft YaHei"/>
+                <a:ea typeface="Microsoft YaHei"/>
+              </a:rPr>
+              <a:t>導演、三幕、OpenRouter</a:t>
+            </a:r>
+          </a:p>
+        </p:txBody>
+      </p:sp>
+      <p:sp>
+        <p:nvSpPr>
+          <p:cNvPr id="11" name="Rounded Rectangle 10"/>
+          <p:cNvSpPr/>
+          <p:nvPr/>
+        </p:nvSpPr>
+        <p:spPr>
+          <a:xfrm>
+            <a:off x="8138160" y="1170432"/>
+            <a:ext cx="3657600" cy="1389888"/>
+          </a:xfrm>
+          <a:prstGeom prst="roundRect">
+            <a:avLst/>
+          </a:prstGeom>
+          <a:solidFill>
+            <a:srgbClr val="14100A"/>
+          </a:solidFill>
+          <a:ln w="15875">
+            <a:solidFill>
+              <a:srgbClr val="D4AF37"/>
+            </a:solidFill>
+          </a:ln>
+        </p:spPr>
+        <p:style>
+          <a:lnRef idx="1">
+            <a:schemeClr val="accent1"/>
+          </a:lnRef>
+          <a:fillRef idx="3">
+            <a:schemeClr val="accent1"/>
+          </a:fillRef>
+          <a:effectRef idx="2">
+            <a:schemeClr val="accent1"/>
+          </a:effectRef>
+          <a:fontRef idx="minor">
+            <a:schemeClr val="lt1"/>
+          </a:fontRef>
+        </p:style>
+        <p:txBody>
+          <a:bodyPr rtlCol="0" anchor="ctr"/>
+          <a:lstStyle/>
+          <a:p>
+            <a:pPr algn="ctr"/>
+          </a:p>
+        </p:txBody>
+      </p:sp>
+      <p:sp>
+        <p:nvSpPr>
+          <p:cNvPr id="12" name="TextBox 11"/>
+          <p:cNvSpPr txBox="1"/>
+          <p:nvPr/>
+        </p:nvSpPr>
+        <p:spPr>
+          <a:xfrm>
+            <a:off x="8321040" y="1335024"/>
+            <a:ext cx="3291840" cy="365760"/>
+          </a:xfrm>
+          <a:prstGeom prst="rect">
+            <a:avLst/>
+          </a:prstGeom>
+          <a:noFill/>
+        </p:spPr>
+        <p:txBody>
+          <a:bodyPr wrap="square">
+            <a:spAutoFit/>
+          </a:bodyPr>
+          <a:lstStyle/>
+          <a:p>
+            <a:pPr algn="l">
+              <a:spcAft>
+                <a:spcPts val="600"/>
+              </a:spcAft>
+            </a:pPr>
+            <a:r>
+              <a:rPr sz="1800" b="1">
+                <a:solidFill>
+                  <a:srgbClr val="7EC8C3"/>
+                </a:solidFill>
+                <a:latin typeface="Microsoft YaHei"/>
+                <a:ea typeface="Microsoft YaHei"/>
+              </a:rPr>
+              <a:t>main.js</a:t>
+            </a:r>
+          </a:p>
+        </p:txBody>
+      </p:sp>
+      <p:sp>
+        <p:nvSpPr>
+          <p:cNvPr id="13" name="TextBox 12"/>
+          <p:cNvSpPr txBox="1"/>
+          <p:nvPr/>
+        </p:nvSpPr>
+        <p:spPr>
+          <a:xfrm>
+            <a:off x="8321040" y="1792224"/>
+            <a:ext cx="3291840" cy="548640"/>
+          </a:xfrm>
+          <a:prstGeom prst="rect">
+            <a:avLst/>
+          </a:prstGeom>
+          <a:noFill/>
+        </p:spPr>
+        <p:txBody>
+          <a:bodyPr wrap="square">
+            <a:spAutoFit/>
+          </a:bodyPr>
+          <a:lstStyle/>
+          <a:p>
+            <a:pPr algn="l">
+              <a:spcAft>
+                <a:spcPts val="600"/>
+              </a:spcAft>
+            </a:pPr>
+            <a:r>
+              <a:rPr sz="1500" b="0">
+                <a:solidFill>
+                  <a:srgbClr val="F4E8C8"/>
+                </a:solidFill>
+                <a:latin typeface="Microsoft YaHei"/>
+                <a:ea typeface="Microsoft YaHei"/>
+              </a:rPr>
+              <a:t>HUD、地圖、檢視、操作</a:t>
+            </a:r>
+          </a:p>
+        </p:txBody>
+      </p:sp>
+      <p:sp>
+        <p:nvSpPr>
+          <p:cNvPr id="14" name="Rounded Rectangle 13"/>
+          <p:cNvSpPr/>
+          <p:nvPr/>
+        </p:nvSpPr>
+        <p:spPr>
+          <a:xfrm>
+            <a:off x="457200" y="2724912"/>
+            <a:ext cx="3657600" cy="1389888"/>
+          </a:xfrm>
+          <a:prstGeom prst="roundRect">
+            <a:avLst/>
+          </a:prstGeom>
+          <a:solidFill>
+            <a:srgbClr val="14100A"/>
+          </a:solidFill>
+          <a:ln w="15875">
+            <a:solidFill>
+              <a:srgbClr val="D4AF37"/>
+            </a:solidFill>
+          </a:ln>
+        </p:spPr>
+        <p:style>
+          <a:lnRef idx="1">
+            <a:schemeClr val="accent1"/>
+          </a:lnRef>
+          <a:fillRef idx="3">
+            <a:schemeClr val="accent1"/>
+          </a:fillRef>
+          <a:effectRef idx="2">
+            <a:schemeClr val="accent1"/>
+          </a:effectRef>
+          <a:fontRef idx="minor">
+            <a:schemeClr val="lt1"/>
+          </a:fontRef>
+        </p:style>
+        <p:txBody>
+          <a:bodyPr rtlCol="0" anchor="ctr"/>
+          <a:lstStyle/>
+          <a:p>
+            <a:pPr algn="ctr"/>
+          </a:p>
+        </p:txBody>
+      </p:sp>
+      <p:sp>
+        <p:nvSpPr>
+          <p:cNvPr id="15" name="TextBox 14"/>
+          <p:cNvSpPr txBox="1"/>
+          <p:nvPr/>
+        </p:nvSpPr>
+        <p:spPr>
+          <a:xfrm>
+            <a:off x="640080" y="2889504"/>
+            <a:ext cx="3291840" cy="365760"/>
+          </a:xfrm>
+          <a:prstGeom prst="rect">
+            <a:avLst/>
+          </a:prstGeom>
+          <a:noFill/>
+        </p:spPr>
+        <p:txBody>
+          <a:bodyPr wrap="square">
+            <a:spAutoFit/>
+          </a:bodyPr>
+          <a:lstStyle/>
+          <a:p>
+            <a:pPr algn="l">
+              <a:spcAft>
+                <a:spcPts val="600"/>
+              </a:spcAft>
+            </a:pPr>
+            <a:r>
+              <a:rPr sz="1800" b="1">
+                <a:solidFill>
+                  <a:srgbClr val="7EC8C3"/>
+                </a:solidFill>
+                <a:latin typeface="Microsoft YaHei"/>
+                <a:ea typeface="Microsoft YaHei"/>
+              </a:rPr>
+              <a:t>style.css</a:t>
+            </a:r>
+          </a:p>
+        </p:txBody>
+      </p:sp>
+      <p:sp>
+        <p:nvSpPr>
+          <p:cNvPr id="16" name="TextBox 15"/>
+          <p:cNvSpPr txBox="1"/>
+          <p:nvPr/>
+        </p:nvSpPr>
+        <p:spPr>
+          <a:xfrm>
+            <a:off x="640080" y="3346704"/>
+            <a:ext cx="3291840" cy="548640"/>
+          </a:xfrm>
+          <a:prstGeom prst="rect">
+            <a:avLst/>
+          </a:prstGeom>
+          <a:noFill/>
+        </p:spPr>
+        <p:txBody>
+          <a:bodyPr wrap="square">
+            <a:spAutoFit/>
+          </a:bodyPr>
+          <a:lstStyle/>
+          <a:p>
+            <a:pPr algn="l">
+              <a:spcAft>
+                <a:spcPts val="600"/>
+              </a:spcAft>
+            </a:pPr>
+            <a:r>
+              <a:rPr sz="1500" b="0">
+                <a:solidFill>
+                  <a:srgbClr val="F4E8C8"/>
+                </a:solidFill>
+                <a:latin typeface="Microsoft YaHei"/>
+                <a:ea typeface="Microsoft YaHei"/>
+              </a:rPr>
+              <a:t>金漆牌坊、墨底描金</a:t>
+            </a:r>
+          </a:p>
+        </p:txBody>
+      </p:sp>
+      <p:sp>
+        <p:nvSpPr>
+          <p:cNvPr id="17" name="Rounded Rectangle 16"/>
+          <p:cNvSpPr/>
+          <p:nvPr/>
+        </p:nvSpPr>
+        <p:spPr>
+          <a:xfrm>
+            <a:off x="4297680" y="2724912"/>
+            <a:ext cx="3657600" cy="1389888"/>
+          </a:xfrm>
+          <a:prstGeom prst="roundRect">
+            <a:avLst/>
+          </a:prstGeom>
+          <a:solidFill>
+            <a:srgbClr val="14100A"/>
+          </a:solidFill>
+          <a:ln w="15875">
+            <a:solidFill>
+              <a:srgbClr val="D4AF37"/>
+            </a:solidFill>
+          </a:ln>
+        </p:spPr>
+        <p:style>
+          <a:lnRef idx="1">
+            <a:schemeClr val="accent1"/>
+          </a:lnRef>
+          <a:fillRef idx="3">
+            <a:schemeClr val="accent1"/>
+          </a:fillRef>
+          <a:effectRef idx="2">
+            <a:schemeClr val="accent1"/>
+          </a:effectRef>
+          <a:fontRef idx="minor">
+            <a:schemeClr val="lt1"/>
+          </a:fontRef>
+        </p:style>
+        <p:txBody>
+          <a:bodyPr rtlCol="0" anchor="ctr"/>
+          <a:lstStyle/>
+          <a:p>
+            <a:pPr algn="ctr"/>
+          </a:p>
+        </p:txBody>
+      </p:sp>
+      <p:sp>
+        <p:nvSpPr>
+          <p:cNvPr id="18" name="TextBox 17"/>
+          <p:cNvSpPr txBox="1"/>
+          <p:nvPr/>
+        </p:nvSpPr>
+        <p:spPr>
+          <a:xfrm>
+            <a:off x="4480560" y="2889504"/>
+            <a:ext cx="3291840" cy="365760"/>
+          </a:xfrm>
+          <a:prstGeom prst="rect">
+            <a:avLst/>
+          </a:prstGeom>
+          <a:noFill/>
+        </p:spPr>
+        <p:txBody>
+          <a:bodyPr wrap="square">
+            <a:spAutoFit/>
+          </a:bodyPr>
+          <a:lstStyle/>
+          <a:p>
+            <a:pPr algn="l">
+              <a:spcAft>
+                <a:spcPts val="600"/>
+              </a:spcAft>
+            </a:pPr>
+            <a:r>
+              <a:rPr sz="1800" b="1">
+                <a:solidFill>
+                  <a:srgbClr val="7EC8C3"/>
+                </a:solidFill>
+                <a:latin typeface="Microsoft YaHei"/>
+                <a:ea typeface="Microsoft YaHei"/>
+              </a:rPr>
+              <a:t>fx.js</a:t>
+            </a:r>
+          </a:p>
+        </p:txBody>
+      </p:sp>
+      <p:sp>
+        <p:nvSpPr>
+          <p:cNvPr id="19" name="TextBox 18"/>
+          <p:cNvSpPr txBox="1"/>
+          <p:nvPr/>
+        </p:nvSpPr>
+        <p:spPr>
+          <a:xfrm>
+            <a:off x="4480560" y="3346704"/>
+            <a:ext cx="3291840" cy="548640"/>
+          </a:xfrm>
+          <a:prstGeom prst="rect">
+            <a:avLst/>
+          </a:prstGeom>
+          <a:noFill/>
+        </p:spPr>
+        <p:txBody>
+          <a:bodyPr wrap="square">
+            <a:spAutoFit/>
+          </a:bodyPr>
+          <a:lstStyle/>
+          <a:p>
+            <a:pPr algn="l">
+              <a:spcAft>
+                <a:spcPts val="600"/>
+              </a:spcAft>
+            </a:pPr>
+            <a:r>
+              <a:rPr sz="1500" b="0">
+                <a:solidFill>
+                  <a:srgbClr val="F4E8C8"/>
+                </a:solidFill>
+                <a:latin typeface="Microsoft YaHei"/>
+                <a:ea typeface="Microsoft YaHei"/>
+              </a:rPr>
+              <a:t>靈塵、聚氣、突破金光</a:t>
+            </a:r>
+          </a:p>
+        </p:txBody>
+      </p:sp>
+      <p:sp>
+        <p:nvSpPr>
+          <p:cNvPr id="20" name="Rounded Rectangle 19"/>
+          <p:cNvSpPr/>
+          <p:nvPr/>
+        </p:nvSpPr>
+        <p:spPr>
+          <a:xfrm>
+            <a:off x="8138160" y="2724912"/>
+            <a:ext cx="3657600" cy="1389888"/>
+          </a:xfrm>
+          <a:prstGeom prst="roundRect">
+            <a:avLst/>
+          </a:prstGeom>
+          <a:solidFill>
+            <a:srgbClr val="14100A"/>
+          </a:solidFill>
+          <a:ln w="15875">
+            <a:solidFill>
+              <a:srgbClr val="D4AF37"/>
+            </a:solidFill>
+          </a:ln>
+        </p:spPr>
+        <p:style>
+          <a:lnRef idx="1">
+            <a:schemeClr val="accent1"/>
+          </a:lnRef>
+          <a:fillRef idx="3">
+            <a:schemeClr val="accent1"/>
+          </a:fillRef>
+          <a:effectRef idx="2">
+            <a:schemeClr val="accent1"/>
+          </a:effectRef>
+          <a:fontRef idx="minor">
+            <a:schemeClr val="lt1"/>
+          </a:fontRef>
+        </p:style>
+        <p:txBody>
+          <a:bodyPr rtlCol="0" anchor="ctr"/>
+          <a:lstStyle/>
+          <a:p>
+            <a:pPr algn="ctr"/>
+          </a:p>
+        </p:txBody>
+      </p:sp>
+      <p:sp>
+        <p:nvSpPr>
+          <p:cNvPr id="21" name="TextBox 20"/>
+          <p:cNvSpPr txBox="1"/>
+          <p:nvPr/>
+        </p:nvSpPr>
+        <p:spPr>
+          <a:xfrm>
+            <a:off x="8321040" y="2889504"/>
+            <a:ext cx="3291840" cy="365760"/>
+          </a:xfrm>
+          <a:prstGeom prst="rect">
+            <a:avLst/>
+          </a:prstGeom>
+          <a:noFill/>
+        </p:spPr>
+        <p:txBody>
+          <a:bodyPr wrap="square">
+            <a:spAutoFit/>
+          </a:bodyPr>
+          <a:lstStyle/>
+          <a:p>
+            <a:pPr algn="l">
+              <a:spcAft>
+                <a:spcPts val="600"/>
+              </a:spcAft>
+            </a:pPr>
+            <a:r>
+              <a:rPr sz="1800" b="1">
+                <a:solidFill>
+                  <a:srgbClr val="7EC8C3"/>
+                </a:solidFill>
+                <a:latin typeface="Microsoft YaHei"/>
+                <a:ea typeface="Microsoft YaHei"/>
+              </a:rPr>
+              <a:t>audio.js</a:t>
+            </a:r>
+          </a:p>
+        </p:txBody>
+      </p:sp>
+      <p:sp>
+        <p:nvSpPr>
+          <p:cNvPr id="22" name="TextBox 21"/>
+          <p:cNvSpPr txBox="1"/>
+          <p:nvPr/>
+        </p:nvSpPr>
+        <p:spPr>
+          <a:xfrm>
+            <a:off x="8321040" y="3346704"/>
+            <a:ext cx="3291840" cy="548640"/>
+          </a:xfrm>
+          <a:prstGeom prst="rect">
+            <a:avLst/>
+          </a:prstGeom>
+          <a:noFill/>
+        </p:spPr>
+        <p:txBody>
+          <a:bodyPr wrap="square">
+            <a:spAutoFit/>
+          </a:bodyPr>
+          <a:lstStyle/>
+          <a:p>
+            <a:pPr algn="l">
+              <a:spcAft>
+                <a:spcPts val="600"/>
+              </a:spcAft>
+            </a:pPr>
+            <a:r>
+              <a:rPr sz="1500" b="0">
+                <a:solidFill>
+                  <a:srgbClr val="F4E8C8"/>
+                </a:solidFill>
+                <a:latin typeface="Microsoft YaHei"/>
+                <a:ea typeface="Microsoft YaHei"/>
+              </a:rPr>
+              <a:t>木魚磬雷 + 嗶哩嵌入</a:t>
+            </a:r>
+          </a:p>
+        </p:txBody>
+      </p:sp>
+      <p:sp>
+        <p:nvSpPr>
+          <p:cNvPr id="23" name="Rounded Rectangle 22"/>
+          <p:cNvSpPr/>
+          <p:nvPr/>
+        </p:nvSpPr>
+        <p:spPr>
+          <a:xfrm>
+            <a:off x="457200" y="4389120"/>
+            <a:ext cx="11247120" cy="1965960"/>
+          </a:xfrm>
+          <a:prstGeom prst="roundRect">
+            <a:avLst/>
+          </a:prstGeom>
+          <a:solidFill>
+            <a:srgbClr val="14100A"/>
+          </a:solidFill>
+          <a:ln w="15875">
+            <a:solidFill>
+              <a:srgbClr val="7EC8C3"/>
+            </a:solidFill>
+          </a:ln>
+        </p:spPr>
+        <p:style>
+          <a:lnRef idx="1">
+            <a:schemeClr val="accent1"/>
+          </a:lnRef>
+          <a:fillRef idx="3">
+            <a:schemeClr val="accent1"/>
+          </a:fillRef>
+          <a:effectRef idx="2">
+            <a:schemeClr val="accent1"/>
+          </a:effectRef>
+          <a:fontRef idx="minor">
+            <a:schemeClr val="lt1"/>
+          </a:fontRef>
+        </p:style>
+        <p:txBody>
+          <a:bodyPr rtlCol="0" anchor="ctr"/>
+          <a:lstStyle/>
+          <a:p>
+            <a:pPr algn="ctr"/>
+          </a:p>
+        </p:txBody>
+      </p:sp>
+      <p:sp>
+        <p:nvSpPr>
+          <p:cNvPr id="24" name="TextBox 23"/>
+          <p:cNvSpPr txBox="1"/>
+          <p:nvPr/>
+        </p:nvSpPr>
+        <p:spPr>
+          <a:xfrm>
+            <a:off x="685800" y="4526280"/>
+            <a:ext cx="10789920" cy="1691640"/>
+          </a:xfrm>
+          <a:prstGeom prst="rect">
+            <a:avLst/>
+          </a:prstGeom>
+          <a:noFill/>
+        </p:spPr>
+        <p:txBody>
+          <a:bodyPr wrap="square">
+            <a:spAutoFit/>
+          </a:bodyPr>
+          <a:lstStyle/>
+          <a:p>
+            <a:pPr algn="l">
+              <a:spcAft>
+                <a:spcPts val="600"/>
+              </a:spcAft>
+            </a:pPr>
+            <a:r>
+              <a:rPr sz="1600" b="1">
+                <a:solidFill>
+                  <a:srgbClr val="7EC8C3"/>
+                </a:solidFill>
+                <a:latin typeface="Microsoft YaHei"/>
+                <a:ea typeface="Microsoft YaHei"/>
+              </a:rPr>
+              <a:t>日常　改規則或文案 → npm run dev → 現場睇一場戲 → git commit</a:t>
+            </a:r>
+          </a:p>
+          <a:p>
+            <a:pPr algn="l">
+              <a:spcAft>
+                <a:spcPts val="600"/>
+              </a:spcAft>
+            </a:pPr>
+            <a:r>
+              <a:rPr sz="1600" b="0">
+                <a:solidFill>
+                  <a:srgbClr val="F4E8C8"/>
+                </a:solidFill>
+                <a:latin typeface="Microsoft YaHei"/>
+                <a:ea typeface="Microsoft YaHei"/>
+              </a:rPr>
+              <a:t>出貨　npm run build → 將 dist 推去 gh-pages → https://yip-lgtm.github.io/family/</a:t>
+            </a:r>
+          </a:p>
+          <a:p>
+            <a:pPr algn="l">
+              <a:spcAft>
+                <a:spcPts val="600"/>
+              </a:spcAft>
+            </a:pPr>
+            <a:r>
+              <a:rPr sz="1500" b="0">
+                <a:solidFill>
+                  <a:srgbClr val="B8A888"/>
+                </a:solidFill>
+                <a:latin typeface="Microsoft YaHei"/>
+                <a:ea typeface="Microsoft YaHei"/>
+              </a:rPr>
+              <a:t>約束　唔下載嗶哩音源 · 唔抄《教父》對白 · Key 只存瀏覽器 · 劇組永遠可代班</a:t>
+            </a:r>
+          </a:p>
+        </p:txBody>
+      </p:sp>
+    </p:spTree>
+  </p:cSld>
+  <p:clrMapOvr>
+    <a:masterClrMapping/>
+  </p:clrMapOvr>
+</p:sld>
+</file>
+
+<file path=ppt/slides/slide9.xml><?xml version="1.0" encoding="utf-8"?>
+<p:sld xmlns:a="http://schemas.openxmlformats.org/drawingml/2006/main" xmlns:p="http://schemas.openxmlformats.org/presentationml/2006/main" xmlns:r="http://schemas.openxmlformats.org/officeDocument/2006/relationships">
+  <p:cSld>
+    <p:bg>
+      <p:bgPr>
+        <a:solidFill>
+          <a:srgbClr val="0B0804"/>
+        </a:solidFill>
+        <a:effectLst/>
+      </p:bgPr>
+    </p:bg>
+    <p:spTree>
+      <p:nvGrpSpPr>
+        <p:cNvPr id="1" name=""/>
+        <p:cNvGrpSpPr/>
+        <p:nvPr/>
+      </p:nvGrpSpPr>
+      <p:grpSpPr/>
+      <p:sp>
+        <p:nvSpPr>
+          <p:cNvPr id="2" name="Rectangle 1"/>
+          <p:cNvSpPr/>
+          <p:nvPr/>
+        </p:nvSpPr>
+        <p:spPr>
+          <a:xfrm>
+            <a:off x="0" y="0"/>
+            <a:ext cx="12191695" cy="54864"/>
+          </a:xfrm>
+          <a:prstGeom prst="rect">
+            <a:avLst/>
+          </a:prstGeom>
+          <a:solidFill>
+            <a:srgbClr val="D4AF37"/>
+          </a:solidFill>
+          <a:ln>
+            <a:noFill/>
+          </a:ln>
+        </p:spPr>
+        <p:style>
+          <a:lnRef idx="1">
+            <a:schemeClr val="accent1"/>
+          </a:lnRef>
+          <a:fillRef idx="3">
+            <a:schemeClr val="accent1"/>
+          </a:fillRef>
+          <a:effectRef idx="2">
+            <a:schemeClr val="accent1"/>
+          </a:effectRef>
+          <a:fontRef idx="minor">
+            <a:schemeClr val="lt1"/>
+          </a:fontRef>
+        </p:style>
+        <p:txBody>
+          <a:bodyPr rtlCol="0" anchor="ctr"/>
+          <a:lstStyle/>
+          <a:p>
+            <a:pPr algn="ctr"/>
+          </a:p>
+        </p:txBody>
+      </p:sp>
+      <p:sp>
+        <p:nvSpPr>
+          <p:cNvPr id="3" name="Rectangle 2"/>
+          <p:cNvSpPr/>
+          <p:nvPr/>
+        </p:nvSpPr>
+        <p:spPr>
+          <a:xfrm>
+            <a:off x="0" y="6803136"/>
+            <a:ext cx="12191695" cy="54864"/>
+          </a:xfrm>
+          <a:prstGeom prst="rect">
+            <a:avLst/>
+          </a:prstGeom>
+          <a:solidFill>
+            <a:srgbClr val="D4AF37"/>
+          </a:solidFill>
+          <a:ln>
+            <a:noFill/>
+          </a:ln>
+        </p:spPr>
+        <p:style>
+          <a:lnRef idx="1">
+            <a:schemeClr val="accent1"/>
+          </a:lnRef>
+          <a:fillRef idx="3">
+            <a:schemeClr val="accent1"/>
+          </a:fillRef>
+          <a:effectRef idx="2">
+            <a:schemeClr val="accent1"/>
+          </a:effectRef>
+          <a:fontRef idx="minor">
+            <a:schemeClr val="lt1"/>
+          </a:fontRef>
+        </p:style>
+        <p:txBody>
+          <a:bodyPr rtlCol="0" anchor="ctr"/>
+          <a:lstStyle/>
+          <a:p>
+            <a:pPr algn="ctr"/>
+          </a:p>
+        </p:txBody>
+      </p:sp>
+      <p:sp>
+        <p:nvSpPr>
+          <p:cNvPr id="4" name="TextBox 3"/>
+          <p:cNvSpPr txBox="1"/>
+          <p:nvPr/>
+        </p:nvSpPr>
+        <p:spPr>
+          <a:xfrm>
+            <a:off x="640080" y="274320"/>
+            <a:ext cx="10972800" cy="777240"/>
+          </a:xfrm>
+          <a:prstGeom prst="rect">
+            <a:avLst/>
+          </a:prstGeom>
+          <a:noFill/>
+        </p:spPr>
+        <p:txBody>
+          <a:bodyPr wrap="square">
+            <a:spAutoFit/>
+          </a:bodyPr>
+          <a:lstStyle/>
+          <a:p>
+            <a:pPr algn="l">
+              <a:spcAft>
+                <a:spcPts val="600"/>
+              </a:spcAft>
+            </a:pPr>
+            <a:r>
+              <a:rPr sz="1400" b="0">
+                <a:solidFill>
+                  <a:srgbClr val="D4AF37"/>
+                </a:solidFill>
+                <a:latin typeface="Microsoft YaHei"/>
+                <a:ea typeface="Microsoft YaHei"/>
+              </a:rPr>
+              <a:t>08  ·  而家點玩（三分鐘）</a:t>
+            </a:r>
+          </a:p>
+          <a:p>
+            <a:pPr algn="l">
+              <a:spcAft>
+                <a:spcPts val="600"/>
+              </a:spcAft>
+            </a:pPr>
+            <a:r>
+              <a:rPr sz="2800" b="1">
+                <a:solidFill>
+                  <a:srgbClr val="F4E8C8"/>
+                </a:solidFill>
+                <a:latin typeface="Microsoft YaHei"/>
+                <a:ea typeface="Microsoft YaHei"/>
+              </a:rPr>
+              <a:t>四步入局，唔使註冊</a:t>
+            </a:r>
+          </a:p>
+        </p:txBody>
+      </p:sp>
+      <p:sp>
+        <p:nvSpPr>
+          <p:cNvPr id="5" name="Rounded Rectangle 4"/>
+          <p:cNvSpPr/>
+          <p:nvPr/>
+        </p:nvSpPr>
+        <p:spPr>
+          <a:xfrm>
+            <a:off x="457200" y="1325880"/>
+            <a:ext cx="2743200" cy="4297680"/>
+          </a:xfrm>
+          <a:prstGeom prst="roundRect">
+            <a:avLst/>
+          </a:prstGeom>
+          <a:solidFill>
+            <a:srgbClr val="14100A"/>
+          </a:solidFill>
+          <a:ln w="15875">
+            <a:solidFill>
+              <a:srgbClr val="D4AF37"/>
+            </a:solidFill>
+          </a:ln>
+        </p:spPr>
+        <p:style>
+          <a:lnRef idx="1">
+            <a:schemeClr val="accent1"/>
+          </a:lnRef>
+          <a:fillRef idx="3">
+            <a:schemeClr val="accent1"/>
+          </a:fillRef>
+          <a:effectRef idx="2">
+            <a:schemeClr val="accent1"/>
+          </a:effectRef>
+          <a:fontRef idx="minor">
+            <a:schemeClr val="lt1"/>
+          </a:fontRef>
+        </p:style>
+        <p:txBody>
+          <a:bodyPr rtlCol="0" anchor="ctr"/>
+          <a:lstStyle/>
+          <a:p>
+            <a:pPr algn="ctr"/>
+          </a:p>
+        </p:txBody>
+      </p:sp>
+      <p:sp>
+        <p:nvSpPr>
+          <p:cNvPr id="6" name="TextBox 5"/>
+          <p:cNvSpPr txBox="1"/>
+          <p:nvPr/>
+        </p:nvSpPr>
+        <p:spPr>
+          <a:xfrm>
+            <a:off x="640080" y="1554480"/>
+            <a:ext cx="2377440" cy="640080"/>
+          </a:xfrm>
+          <a:prstGeom prst="rect">
+            <a:avLst/>
+          </a:prstGeom>
+          <a:noFill/>
+        </p:spPr>
+        <p:txBody>
+          <a:bodyPr wrap="square">
+            <a:spAutoFit/>
+          </a:bodyPr>
+          <a:lstStyle/>
+          <a:p>
             <a:pPr algn="ctr">
               <a:spcAft>
                 <a:spcPts val="600"/>
               </a:spcAft>
             </a:pPr>
             <a:r>
-              <a:rPr sz="1600" b="0">
+              <a:rPr sz="3600" b="1">
+                <a:solidFill>
+                  <a:srgbClr val="D4AF37"/>
+                </a:solidFill>
+                <a:latin typeface="Microsoft YaHei"/>
+                <a:ea typeface="Microsoft YaHei"/>
+              </a:rPr>
+              <a:t>1</a:t>
+            </a:r>
+          </a:p>
+        </p:txBody>
+      </p:sp>
+      <p:sp>
+        <p:nvSpPr>
+          <p:cNvPr id="7" name="TextBox 6"/>
+          <p:cNvSpPr txBox="1"/>
+          <p:nvPr/>
+        </p:nvSpPr>
+        <p:spPr>
+          <a:xfrm>
+            <a:off x="640080" y="2286000"/>
+            <a:ext cx="2377440" cy="640080"/>
+          </a:xfrm>
+          <a:prstGeom prst="rect">
+            <a:avLst/>
+          </a:prstGeom>
+          <a:noFill/>
+        </p:spPr>
+        <p:txBody>
+          <a:bodyPr wrap="square">
+            <a:spAutoFit/>
+          </a:bodyPr>
+          <a:lstStyle/>
+          <a:p>
+            <a:pPr algn="ctr">
+              <a:spcAft>
+                <a:spcPts val="600"/>
+              </a:spcAft>
+            </a:pPr>
+            <a:r>
+              <a:rPr sz="1800" b="1">
+                <a:solidFill>
+                  <a:srgbClr val="F4E8C8"/>
+                </a:solidFill>
+                <a:latin typeface="Microsoft YaHei"/>
+                <a:ea typeface="Microsoft YaHei"/>
+              </a:rPr>
+              <a:t>打開連結</a:t>
+            </a:r>
+          </a:p>
+        </p:txBody>
+      </p:sp>
+      <p:sp>
+        <p:nvSpPr>
+          <p:cNvPr id="8" name="TextBox 7"/>
+          <p:cNvSpPr txBox="1"/>
+          <p:nvPr/>
+        </p:nvSpPr>
+        <p:spPr>
+          <a:xfrm>
+            <a:off x="594360" y="3063240"/>
+            <a:ext cx="2468880" cy="2194560"/>
+          </a:xfrm>
+          <a:prstGeom prst="rect">
+            <a:avLst/>
+          </a:prstGeom>
+          <a:noFill/>
+        </p:spPr>
+        <p:txBody>
+          <a:bodyPr wrap="square">
+            <a:spAutoFit/>
+          </a:bodyPr>
+          <a:lstStyle/>
+          <a:p>
+            <a:pPr algn="ctr">
+              <a:spcAft>
+                <a:spcPts val="600"/>
+              </a:spcAft>
+            </a:pPr>
+            <a:r>
+              <a:rPr sz="1500" b="0">
                 <a:solidFill>
                   <a:srgbClr val="B8A888"/>
                 </a:solidFill>
                 <a:latin typeface="Microsoft YaHei"/>
                 <a:ea typeface="Microsoft YaHei"/>
               </a:rPr>
-              <a:t>開源 · 瀏覽器即玩 · Key 可選 · 劇組永遠代班</a:t>
+              <a:t>yip-lgtm.github.io/family
+撳「承天命」。</a:t>
+            </a:r>
+          </a:p>
+        </p:txBody>
+      </p:sp>
+      <p:sp>
+        <p:nvSpPr>
+          <p:cNvPr id="9" name="Rounded Rectangle 8"/>
+          <p:cNvSpPr/>
+          <p:nvPr/>
+        </p:nvSpPr>
+        <p:spPr>
+          <a:xfrm>
+            <a:off x="3383280" y="1325880"/>
+            <a:ext cx="2743200" cy="4297680"/>
+          </a:xfrm>
+          <a:prstGeom prst="roundRect">
+            <a:avLst/>
+          </a:prstGeom>
+          <a:solidFill>
+            <a:srgbClr val="14100A"/>
+          </a:solidFill>
+          <a:ln w="15875">
+            <a:solidFill>
+              <a:srgbClr val="D4AF37"/>
+            </a:solidFill>
+          </a:ln>
+        </p:spPr>
+        <p:style>
+          <a:lnRef idx="1">
+            <a:schemeClr val="accent1"/>
+          </a:lnRef>
+          <a:fillRef idx="3">
+            <a:schemeClr val="accent1"/>
+          </a:fillRef>
+          <a:effectRef idx="2">
+            <a:schemeClr val="accent1"/>
+          </a:effectRef>
+          <a:fontRef idx="minor">
+            <a:schemeClr val="lt1"/>
+          </a:fontRef>
+        </p:style>
+        <p:txBody>
+          <a:bodyPr rtlCol="0" anchor="ctr"/>
+          <a:lstStyle/>
+          <a:p>
+            <a:pPr algn="ctr"/>
+          </a:p>
+        </p:txBody>
+      </p:sp>
+      <p:sp>
+        <p:nvSpPr>
+          <p:cNvPr id="10" name="TextBox 9"/>
+          <p:cNvSpPr txBox="1"/>
+          <p:nvPr/>
+        </p:nvSpPr>
+        <p:spPr>
+          <a:xfrm>
+            <a:off x="3566160" y="1554480"/>
+            <a:ext cx="2377440" cy="640080"/>
+          </a:xfrm>
+          <a:prstGeom prst="rect">
+            <a:avLst/>
+          </a:prstGeom>
+          <a:noFill/>
+        </p:spPr>
+        <p:txBody>
+          <a:bodyPr wrap="square">
+            <a:spAutoFit/>
+          </a:bodyPr>
+          <a:lstStyle/>
+          <a:p>
+            <a:pPr algn="ctr">
+              <a:spcAft>
+                <a:spcPts val="600"/>
+              </a:spcAft>
+            </a:pPr>
+            <a:r>
+              <a:rPr sz="3600" b="1">
+                <a:solidFill>
+                  <a:srgbClr val="D4AF37"/>
+                </a:solidFill>
+                <a:latin typeface="Microsoft YaHei"/>
+                <a:ea typeface="Microsoft YaHei"/>
+              </a:rPr>
+              <a:t>2</a:t>
+            </a:r>
+          </a:p>
+        </p:txBody>
+      </p:sp>
+      <p:sp>
+        <p:nvSpPr>
+          <p:cNvPr id="11" name="TextBox 10"/>
+          <p:cNvSpPr txBox="1"/>
+          <p:nvPr/>
+        </p:nvSpPr>
+        <p:spPr>
+          <a:xfrm>
+            <a:off x="3566160" y="2286000"/>
+            <a:ext cx="2377440" cy="640080"/>
+          </a:xfrm>
+          <a:prstGeom prst="rect">
+            <a:avLst/>
+          </a:prstGeom>
+          <a:noFill/>
+        </p:spPr>
+        <p:txBody>
+          <a:bodyPr wrap="square">
+            <a:spAutoFit/>
+          </a:bodyPr>
+          <a:lstStyle/>
+          <a:p>
+            <a:pPr algn="ctr">
+              <a:spcAft>
+                <a:spcPts val="600"/>
+              </a:spcAft>
+            </a:pPr>
+            <a:r>
+              <a:rPr sz="1800" b="1">
+                <a:solidFill>
+                  <a:srgbClr val="F4E8C8"/>
+                </a:solidFill>
+                <a:latin typeface="Microsoft YaHei"/>
+                <a:ea typeface="Microsoft YaHei"/>
+              </a:rPr>
+              <a:t>睇一個人</a:t>
+            </a:r>
+          </a:p>
+        </p:txBody>
+      </p:sp>
+      <p:sp>
+        <p:nvSpPr>
+          <p:cNvPr id="12" name="TextBox 11"/>
+          <p:cNvSpPr txBox="1"/>
+          <p:nvPr/>
+        </p:nvSpPr>
+        <p:spPr>
+          <a:xfrm>
+            <a:off x="3520440" y="3063240"/>
+            <a:ext cx="2468880" cy="2194560"/>
+          </a:xfrm>
+          <a:prstGeom prst="rect">
+            <a:avLst/>
+          </a:prstGeom>
+          <a:noFill/>
+        </p:spPr>
+        <p:txBody>
+          <a:bodyPr wrap="square">
+            <a:spAutoFit/>
+          </a:bodyPr>
+          <a:lstStyle/>
+          <a:p>
+            <a:pPr algn="ctr">
+              <a:spcAft>
+                <a:spcPts val="600"/>
+              </a:spcAft>
+            </a:pPr>
+            <a:r>
+              <a:rPr sz="1500" b="0">
+                <a:solidFill>
+                  <a:srgbClr val="B8A888"/>
+                </a:solidFill>
+                <a:latin typeface="Microsoft YaHei"/>
+                <a:ea typeface="Microsoft YaHei"/>
+              </a:rPr>
+              <a:t>點沈清梧或者葉疏影。
+記住佢心事同關係。</a:t>
+            </a:r>
+          </a:p>
+        </p:txBody>
+      </p:sp>
+      <p:sp>
+        <p:nvSpPr>
+          <p:cNvPr id="13" name="Rounded Rectangle 12"/>
+          <p:cNvSpPr/>
+          <p:nvPr/>
+        </p:nvSpPr>
+        <p:spPr>
+          <a:xfrm>
+            <a:off x="6309360" y="1325880"/>
+            <a:ext cx="2743200" cy="4297680"/>
+          </a:xfrm>
+          <a:prstGeom prst="roundRect">
+            <a:avLst/>
+          </a:prstGeom>
+          <a:solidFill>
+            <a:srgbClr val="14100A"/>
+          </a:solidFill>
+          <a:ln w="15875">
+            <a:solidFill>
+              <a:srgbClr val="D4AF37"/>
+            </a:solidFill>
+          </a:ln>
+        </p:spPr>
+        <p:style>
+          <a:lnRef idx="1">
+            <a:schemeClr val="accent1"/>
+          </a:lnRef>
+          <a:fillRef idx="3">
+            <a:schemeClr val="accent1"/>
+          </a:fillRef>
+          <a:effectRef idx="2">
+            <a:schemeClr val="accent1"/>
+          </a:effectRef>
+          <a:fontRef idx="minor">
+            <a:schemeClr val="lt1"/>
+          </a:fontRef>
+        </p:style>
+        <p:txBody>
+          <a:bodyPr rtlCol="0" anchor="ctr"/>
+          <a:lstStyle/>
+          <a:p>
+            <a:pPr algn="ctr"/>
+          </a:p>
+        </p:txBody>
+      </p:sp>
+      <p:sp>
+        <p:nvSpPr>
+          <p:cNvPr id="14" name="TextBox 13"/>
+          <p:cNvSpPr txBox="1"/>
+          <p:nvPr/>
+        </p:nvSpPr>
+        <p:spPr>
+          <a:xfrm>
+            <a:off x="6492240" y="1554480"/>
+            <a:ext cx="2377440" cy="640080"/>
+          </a:xfrm>
+          <a:prstGeom prst="rect">
+            <a:avLst/>
+          </a:prstGeom>
+          <a:noFill/>
+        </p:spPr>
+        <p:txBody>
+          <a:bodyPr wrap="square">
+            <a:spAutoFit/>
+          </a:bodyPr>
+          <a:lstStyle/>
+          <a:p>
+            <a:pPr algn="ctr">
+              <a:spcAft>
+                <a:spcPts val="600"/>
+              </a:spcAft>
+            </a:pPr>
+            <a:r>
+              <a:rPr sz="3600" b="1">
+                <a:solidFill>
+                  <a:srgbClr val="D4AF37"/>
+                </a:solidFill>
+                <a:latin typeface="Microsoft YaHei"/>
+                <a:ea typeface="Microsoft YaHei"/>
+              </a:rPr>
+              <a:t>3</a:t>
+            </a:r>
+          </a:p>
+        </p:txBody>
+      </p:sp>
+      <p:sp>
+        <p:nvSpPr>
+          <p:cNvPr id="15" name="TextBox 14"/>
+          <p:cNvSpPr txBox="1"/>
+          <p:nvPr/>
+        </p:nvSpPr>
+        <p:spPr>
+          <a:xfrm>
+            <a:off x="6492240" y="2286000"/>
+            <a:ext cx="2377440" cy="640080"/>
+          </a:xfrm>
+          <a:prstGeom prst="rect">
+            <a:avLst/>
+          </a:prstGeom>
+          <a:noFill/>
+        </p:spPr>
+        <p:txBody>
+          <a:bodyPr wrap="square">
+            <a:spAutoFit/>
+          </a:bodyPr>
+          <a:lstStyle/>
+          <a:p>
+            <a:pPr algn="ctr">
+              <a:spcAft>
+                <a:spcPts val="600"/>
+              </a:spcAft>
+            </a:pPr>
+            <a:r>
+              <a:rPr sz="1800" b="1">
+                <a:solidFill>
+                  <a:srgbClr val="F4E8C8"/>
+                </a:solidFill>
+                <a:latin typeface="Microsoft YaHei"/>
+                <a:ea typeface="Microsoft YaHei"/>
+              </a:rPr>
+              <a:t>等兩場戲</a:t>
+            </a:r>
+          </a:p>
+        </p:txBody>
+      </p:sp>
+      <p:sp>
+        <p:nvSpPr>
+          <p:cNvPr id="16" name="TextBox 15"/>
+          <p:cNvSpPr txBox="1"/>
+          <p:nvPr/>
+        </p:nvSpPr>
+        <p:spPr>
+          <a:xfrm>
+            <a:off x="6446520" y="3063240"/>
+            <a:ext cx="2468880" cy="2194560"/>
+          </a:xfrm>
+          <a:prstGeom prst="rect">
+            <a:avLst/>
+          </a:prstGeom>
+          <a:noFill/>
+        </p:spPr>
+        <p:txBody>
+          <a:bodyPr wrap="square">
+            <a:spAutoFit/>
+          </a:bodyPr>
+          <a:lstStyle/>
+          <a:p>
+            <a:pPr algn="ctr">
+              <a:spcAft>
+                <a:spcPts val="600"/>
+              </a:spcAft>
+            </a:pPr>
+            <a:r>
+              <a:rPr sz="1500" b="0">
+                <a:solidFill>
+                  <a:srgbClr val="B8A888"/>
+                </a:solidFill>
+                <a:latin typeface="Microsoft YaHei"/>
+                <a:ea typeface="Microsoft YaHei"/>
+              </a:rPr>
+              <a:t>開時間。睇編劇組出第一、第二場。</a:t>
+            </a:r>
+          </a:p>
+        </p:txBody>
+      </p:sp>
+      <p:sp>
+        <p:nvSpPr>
+          <p:cNvPr id="17" name="Rounded Rectangle 16"/>
+          <p:cNvSpPr/>
+          <p:nvPr/>
+        </p:nvSpPr>
+        <p:spPr>
+          <a:xfrm>
+            <a:off x="9235440" y="1325880"/>
+            <a:ext cx="2743200" cy="4297680"/>
+          </a:xfrm>
+          <a:prstGeom prst="roundRect">
+            <a:avLst/>
+          </a:prstGeom>
+          <a:solidFill>
+            <a:srgbClr val="14100A"/>
+          </a:solidFill>
+          <a:ln w="15875">
+            <a:solidFill>
+              <a:srgbClr val="D4AF37"/>
+            </a:solidFill>
+          </a:ln>
+        </p:spPr>
+        <p:style>
+          <a:lnRef idx="1">
+            <a:schemeClr val="accent1"/>
+          </a:lnRef>
+          <a:fillRef idx="3">
+            <a:schemeClr val="accent1"/>
+          </a:fillRef>
+          <a:effectRef idx="2">
+            <a:schemeClr val="accent1"/>
+          </a:effectRef>
+          <a:fontRef idx="minor">
+            <a:schemeClr val="lt1"/>
+          </a:fontRef>
+        </p:style>
+        <p:txBody>
+          <a:bodyPr rtlCol="0" anchor="ctr"/>
+          <a:lstStyle/>
+          <a:p>
+            <a:pPr algn="ctr"/>
+          </a:p>
+        </p:txBody>
+      </p:sp>
+      <p:sp>
+        <p:nvSpPr>
+          <p:cNvPr id="18" name="TextBox 17"/>
+          <p:cNvSpPr txBox="1"/>
+          <p:nvPr/>
+        </p:nvSpPr>
+        <p:spPr>
+          <a:xfrm>
+            <a:off x="9418320" y="1554480"/>
+            <a:ext cx="2377440" cy="640080"/>
+          </a:xfrm>
+          <a:prstGeom prst="rect">
+            <a:avLst/>
+          </a:prstGeom>
+          <a:noFill/>
+        </p:spPr>
+        <p:txBody>
+          <a:bodyPr wrap="square">
+            <a:spAutoFit/>
+          </a:bodyPr>
+          <a:lstStyle/>
+          <a:p>
+            <a:pPr algn="ctr">
+              <a:spcAft>
+                <a:spcPts val="600"/>
+              </a:spcAft>
+            </a:pPr>
+            <a:r>
+              <a:rPr sz="3600" b="1">
+                <a:solidFill>
+                  <a:srgbClr val="D4AF37"/>
+                </a:solidFill>
+                <a:latin typeface="Microsoft YaHei"/>
+                <a:ea typeface="Microsoft YaHei"/>
+              </a:rPr>
+              <a:t>4</a:t>
+            </a:r>
+          </a:p>
+        </p:txBody>
+      </p:sp>
+      <p:sp>
+        <p:nvSpPr>
+          <p:cNvPr id="19" name="TextBox 18"/>
+          <p:cNvSpPr txBox="1"/>
+          <p:nvPr/>
+        </p:nvSpPr>
+        <p:spPr>
+          <a:xfrm>
+            <a:off x="9418320" y="2286000"/>
+            <a:ext cx="2377440" cy="640080"/>
+          </a:xfrm>
+          <a:prstGeom prst="rect">
+            <a:avLst/>
+          </a:prstGeom>
+          <a:noFill/>
+        </p:spPr>
+        <p:txBody>
+          <a:bodyPr wrap="square">
+            <a:spAutoFit/>
+          </a:bodyPr>
+          <a:lstStyle/>
+          <a:p>
+            <a:pPr algn="ctr">
+              <a:spcAft>
+                <a:spcPts val="600"/>
+              </a:spcAft>
+            </a:pPr>
+            <a:r>
+              <a:rPr sz="1800" b="1">
+                <a:solidFill>
+                  <a:srgbClr val="F4E8C8"/>
+                </a:solidFill>
+                <a:latin typeface="Microsoft YaHei"/>
+                <a:ea typeface="Microsoft YaHei"/>
+              </a:rPr>
+              <a:t>先改一次命</a:t>
+            </a:r>
+          </a:p>
+        </p:txBody>
+      </p:sp>
+      <p:sp>
+        <p:nvSpPr>
+          <p:cNvPr id="20" name="TextBox 19"/>
+          <p:cNvSpPr txBox="1"/>
+          <p:nvPr/>
+        </p:nvSpPr>
+        <p:spPr>
+          <a:xfrm>
+            <a:off x="9372600" y="3063240"/>
+            <a:ext cx="2468880" cy="2194560"/>
+          </a:xfrm>
+          <a:prstGeom prst="rect">
+            <a:avLst/>
+          </a:prstGeom>
+          <a:noFill/>
+        </p:spPr>
+        <p:txBody>
+          <a:bodyPr wrap="square">
+            <a:spAutoFit/>
+          </a:bodyPr>
+          <a:lstStyle/>
+          <a:p>
+            <a:pPr algn="ctr">
+              <a:spcAft>
+                <a:spcPts val="600"/>
+              </a:spcAft>
+            </a:pPr>
+            <a:r>
+              <a:rPr sz="1500" b="0">
+                <a:solidFill>
+                  <a:srgbClr val="B8A888"/>
+                </a:solidFill>
+                <a:latin typeface="Microsoft YaHei"/>
+                <a:ea typeface="Microsoft YaHei"/>
+              </a:rPr>
+              <a:t>賜福或者天劫。
+然後停手，睇後果。</a:t>
             </a:r>
           </a:p>
         </p:txBody>

</xml_diff>